<commit_message>
Add Claude Frontier Academy section to training notes
New section covering Anthropic's $100M enterprise AI talent
development program (FDE residency, program structure, participating
organizations), added to both the Japanese pptx and English markdown.

Co-Authored-By: Claude Sonnet 5 <noreply@anthropic.com>
Claude-Session: https://claude.ai/code/session_011KHa4MUwNn3SuV95WoncKQ
</commit_message>
<xml_diff>
--- a/claude-camp-training-notes.pptx
+++ b/claude-camp-training-notes.pptx
@@ -44,9 +44,10 @@
     <p:sldId id="292" r:id="rId38"/>
     <p:sldId id="293" r:id="rId39"/>
     <p:sldId id="294" r:id="rId40"/>
+    <p:sldId id="295" r:id="rId41"/>
   </p:sldIdLst>
   <p:notesMasterIdLst>
-    <p:notesMasterId r:id="rId41"/>
+    <p:notesMasterId r:id="rId42"/>
   </p:notesMasterIdLst>
   <p:sldSz cx="12192000" cy="6858000"/>
   <p:notesSz cx="6858000" cy="12192000"/>
@@ -3468,6 +3469,94 @@
             <a:fld id="{F7021451-1387-4CA6-816F-3879F97B5CBC}" type="slidenum">
               <a:rPr lang="en-US"/>
               <a:t>4</a:t>
+            </a:fld>
+            <a:endParaRPr lang="en-US"/>
+          </a:p>
+        </p:txBody>
+      </p:sp>
+    </p:spTree>
+    <p:extLst>
+      <p:ext uri="{BB962C8B-B14F-4D97-AF65-F5344CB8AC3E}">
+        <p14:creationId xmlns:p14="http://schemas.microsoft.com/office/powerpoint/2010/main" val="1024086991"/>
+      </p:ext>
+    </p:extLst>
+  </p:cSld>
+  <p:clrMapOvr>
+    <a:masterClrMapping/>
+  </p:clrMapOvr>
+</p:notes>
+</file>
+
+<file path=ppt/notesSlides/notesSlide40.xml><?xml version="1.0" encoding="utf-8"?>
+<p:notes xmlns:a="http://schemas.openxmlformats.org/drawingml/2006/main" xmlns:r="http://schemas.openxmlformats.org/officeDocument/2006/relationships" xmlns:p="http://schemas.openxmlformats.org/presentationml/2006/main">
+  <p:cSld>
+    <p:spTree>
+      <p:nvGrpSpPr>
+        <p:cNvPr id="1" name=""/>
+        <p:cNvGrpSpPr/>
+        <p:nvPr/>
+      </p:nvGrpSpPr>
+      <p:grpSpPr>
+        <a:xfrm>
+          <a:off x="0" y="0"/>
+          <a:ext cx="0" cy="0"/>
+          <a:chOff x="0" y="0"/>
+          <a:chExt cx="0" cy="0"/>
+        </a:xfrm>
+      </p:grpSpPr>
+      <p:sp>
+        <p:nvSpPr>
+          <p:cNvPr id="2" name="Slide Image Placeholder 1"/>
+          <p:cNvSpPr>
+            <a:spLocks noGrp="1" noRot="1" noChangeAspect="1"/>
+          </p:cNvSpPr>
+          <p:nvPr>
+            <p:ph type="sldImg"/>
+          </p:nvPr>
+        </p:nvSpPr>
+        <p:spPr/>
+      </p:sp>
+      <p:sp>
+        <p:nvSpPr>
+          <p:cNvPr id="3" name="Notes Placeholder 2"/>
+          <p:cNvSpPr>
+            <a:spLocks noGrp="1"/>
+          </p:cNvSpPr>
+          <p:nvPr>
+            <p:ph type="body" idx="1"/>
+          </p:nvPr>
+        </p:nvSpPr>
+        <p:spPr/>
+        <p:txBody>
+          <a:bodyPr/>
+          <a:lstStyle/>
+          <a:p>
+            <a:r>
+              <a:rPr lang="en-US" dirty="0"/>
+              <a:t/>
+            </a:r>
+            <a:endParaRPr lang="en-US" dirty="0"/>
+          </a:p>
+        </p:txBody>
+      </p:sp>
+      <p:sp>
+        <p:nvSpPr>
+          <p:cNvPr id="4" name="Slide Number Placeholder 3"/>
+          <p:cNvSpPr>
+            <a:spLocks noGrp="1"/>
+          </p:cNvSpPr>
+          <p:nvPr>
+            <p:ph type="sldNum" sz="quarter" idx="10"/>
+          </p:nvPr>
+        </p:nvSpPr>
+        <p:spPr/>
+        <p:txBody>
+          <a:bodyPr/>
+          <a:lstStyle/>
+          <a:p>
+            <a:fld id="{F7021451-1387-4CA6-816F-3879F97B5CBC}" type="slidenum">
+              <a:rPr lang="en-US"/>
+              <a:t>40</a:t>
             </a:fld>
             <a:endParaRPr lang="en-US"/>
           </a:p>
@@ -4373,7 +4462,7 @@
                 <a:ea typeface="Calibri" pitchFamily="34" charset="-122"/>
                 <a:cs typeface="Calibri" pitchFamily="34" charset="-120"/>
               </a:rPr>
-              <a:t>Claude Academy「Claude Code 101」・公式Quickstart・Claude Camp講演5本のまとめ</a:t>
+              <a:t>Claude Academy「Claude Code 101」・公式Quickstart・Claude Camp講演5本・Claude Frontier Academyのまとめ</a:t>
             </a:r>
             <a:endParaRPr lang="en-US" sz="1600" dirty="0"/>
           </a:p>
@@ -10620,8 +10709,8 @@
         </p:nvSpPr>
         <p:spPr>
           <a:xfrm>
-            <a:off x="640080" y="1188720"/>
-            <a:ext cx="438912" cy="438912"/>
+            <a:off x="640080" y="1051560"/>
+            <a:ext cx="402336" cy="402336"/>
           </a:xfrm>
           <a:prstGeom prst="ellipse">
             <a:avLst/>
@@ -10640,8 +10729,8 @@
         </p:nvSpPr>
         <p:spPr>
           <a:xfrm>
-            <a:off x="640080" y="1188720"/>
-            <a:ext cx="438912" cy="438912"/>
+            <a:off x="640080" y="1051560"/>
+            <a:ext cx="402336" cy="402336"/>
           </a:xfrm>
           <a:prstGeom prst="rect">
             <a:avLst/>
@@ -10657,15 +10746,54 @@
               <a:buNone/>
             </a:pPr>
             <a:r>
+              <a:rPr lang="en-US" sz="1300" b="1" dirty="0">
+                <a:solidFill>
+                  <a:srgbClr val="FFFFFF"/>
+                </a:solidFill>
+                <a:latin typeface="Calibri" pitchFamily="34" charset="0"/>
+                <a:ea typeface="Calibri" pitchFamily="34" charset="-122"/>
+                <a:cs typeface="Calibri" pitchFamily="34" charset="-120"/>
+              </a:rPr>
+              <a:t>1</a:t>
+            </a:r>
+            <a:endParaRPr lang="en-US" sz="1300" dirty="0"/>
+          </a:p>
+        </p:txBody>
+      </p:sp>
+      <p:sp>
+        <p:nvSpPr>
+          <p:cNvPr id="5" name="Text 3"/>
+          <p:cNvSpPr txBox="1"/>
+          <p:nvPr/>
+        </p:nvSpPr>
+        <p:spPr>
+          <a:xfrm>
+            <a:off x="1261872" y="1024128"/>
+            <a:ext cx="9966960" cy="292608"/>
+          </a:xfrm>
+          <a:prstGeom prst="rect">
+            <a:avLst/>
+          </a:prstGeom>
+          <a:noFill/>
+          <a:ln/>
+        </p:spPr>
+        <p:txBody>
+          <a:bodyPr wrap="square" lIns="0" tIns="0" rIns="0" bIns="0" rtlCol="0" anchor="ctr"/>
+          <a:lstStyle/>
+          <a:p>
+            <a:pPr indent="0" marL="0">
+              <a:buNone/>
+            </a:pPr>
+            <a:r>
               <a:rPr lang="en-US" sz="1400" b="1" dirty="0">
                 <a:solidFill>
-                  <a:srgbClr val="FFFFFF"/>
-                </a:solidFill>
-                <a:latin typeface="Calibri" pitchFamily="34" charset="0"/>
-                <a:ea typeface="Calibri" pitchFamily="34" charset="-122"/>
-                <a:cs typeface="Calibri" pitchFamily="34" charset="-120"/>
-              </a:rPr>
-              <a:t>1</a:t>
+                  <a:srgbClr val="1F1E1D"/>
+                </a:solidFill>
+                <a:latin typeface="Calibri" pitchFamily="34" charset="0"/>
+                <a:ea typeface="Calibri" pitchFamily="34" charset="-122"/>
+                <a:cs typeface="Calibri" pitchFamily="34" charset="-120"/>
+              </a:rPr>
+              <a:t>Claude Academy: Claude Code 101 コース</a:t>
             </a:r>
             <a:endParaRPr lang="en-US" sz="1400" dirty="0"/>
           </a:p>
@@ -10673,69 +10801,30 @@
       </p:sp>
       <p:sp>
         <p:nvSpPr>
-          <p:cNvPr id="5" name="Text 3"/>
-          <p:cNvSpPr txBox="1"/>
-          <p:nvPr/>
-        </p:nvSpPr>
-        <p:spPr>
-          <a:xfrm>
-            <a:off x="1298448" y="1161288"/>
-            <a:ext cx="9875520" cy="320040"/>
-          </a:xfrm>
-          <a:prstGeom prst="rect">
-            <a:avLst/>
-          </a:prstGeom>
-          <a:noFill/>
-          <a:ln/>
-        </p:spPr>
-        <p:txBody>
-          <a:bodyPr wrap="square" lIns="0" tIns="0" rIns="0" bIns="0" rtlCol="0" anchor="ctr"/>
-          <a:lstStyle/>
-          <a:p>
-            <a:pPr indent="0" marL="0">
-              <a:buNone/>
-            </a:pPr>
-            <a:r>
-              <a:rPr lang="en-US" sz="1500" b="1" dirty="0">
-                <a:solidFill>
-                  <a:srgbClr val="1F1E1D"/>
-                </a:solidFill>
-                <a:latin typeface="Calibri" pitchFamily="34" charset="0"/>
-                <a:ea typeface="Calibri" pitchFamily="34" charset="-122"/>
-                <a:cs typeface="Calibri" pitchFamily="34" charset="-120"/>
-              </a:rPr>
-              <a:t>Claude Academy: Claude Code 101 コース</a:t>
-            </a:r>
-            <a:endParaRPr lang="en-US" sz="1500" dirty="0"/>
-          </a:p>
-        </p:txBody>
-      </p:sp>
-      <p:sp>
-        <p:nvSpPr>
           <p:cNvPr id="6" name="Text 4"/>
           <p:cNvSpPr txBox="1"/>
           <p:nvPr/>
         </p:nvSpPr>
         <p:spPr>
           <a:xfrm>
-            <a:off x="1298448" y="1463040"/>
-            <a:ext cx="9875520" cy="320040"/>
-          </a:xfrm>
-          <a:prstGeom prst="rect">
-            <a:avLst/>
-          </a:prstGeom>
-          <a:noFill/>
-          <a:ln/>
-        </p:spPr>
-        <p:txBody>
-          <a:bodyPr wrap="square" lIns="0" tIns="0" rIns="0" bIns="0" rtlCol="0" anchor="ctr"/>
-          <a:lstStyle/>
-          <a:p>
-            <a:pPr indent="0" marL="0">
-              <a:buNone/>
-            </a:pPr>
-            <a:r>
-              <a:rPr lang="en-US" sz="1100" dirty="0">
+            <a:off x="1261872" y="1298448"/>
+            <a:ext cx="9966960" cy="292608"/>
+          </a:xfrm>
+          <a:prstGeom prst="rect">
+            <a:avLst/>
+          </a:prstGeom>
+          <a:noFill/>
+          <a:ln/>
+        </p:spPr>
+        <p:txBody>
+          <a:bodyPr wrap="square" lIns="0" tIns="0" rIns="0" bIns="0" rtlCol="0" anchor="ctr"/>
+          <a:lstStyle/>
+          <a:p>
+            <a:pPr indent="0" marL="0">
+              <a:buNone/>
+            </a:pPr>
+            <a:r>
+              <a:rPr lang="en-US" sz="1050" dirty="0">
                 <a:solidFill>
                   <a:srgbClr val="6B6862"/>
                 </a:solidFill>
@@ -10745,7 +10834,7 @@
               </a:rPr>
               <a:t>公式自習コースの全体構成</a:t>
             </a:r>
-            <a:endParaRPr lang="en-US" sz="1100" dirty="0"/>
+            <a:endParaRPr lang="en-US" sz="1050" dirty="0"/>
           </a:p>
         </p:txBody>
       </p:sp>
@@ -10757,8 +10846,8 @@
         </p:nvSpPr>
         <p:spPr>
           <a:xfrm>
-            <a:off x="640080" y="1947672"/>
-            <a:ext cx="438912" cy="438912"/>
+            <a:off x="640080" y="1737360"/>
+            <a:ext cx="402336" cy="402336"/>
           </a:xfrm>
           <a:prstGeom prst="ellipse">
             <a:avLst/>
@@ -10777,8 +10866,8 @@
         </p:nvSpPr>
         <p:spPr>
           <a:xfrm>
-            <a:off x="640080" y="1947672"/>
-            <a:ext cx="438912" cy="438912"/>
+            <a:off x="640080" y="1737360"/>
+            <a:ext cx="402336" cy="402336"/>
           </a:xfrm>
           <a:prstGeom prst="rect">
             <a:avLst/>
@@ -10794,15 +10883,54 @@
               <a:buNone/>
             </a:pPr>
             <a:r>
+              <a:rPr lang="en-US" sz="1300" b="1" dirty="0">
+                <a:solidFill>
+                  <a:srgbClr val="FFFFFF"/>
+                </a:solidFill>
+                <a:latin typeface="Calibri" pitchFamily="34" charset="0"/>
+                <a:ea typeface="Calibri" pitchFamily="34" charset="-122"/>
+                <a:cs typeface="Calibri" pitchFamily="34" charset="-120"/>
+              </a:rPr>
+              <a:t>2</a:t>
+            </a:r>
+            <a:endParaRPr lang="en-US" sz="1300" dirty="0"/>
+          </a:p>
+        </p:txBody>
+      </p:sp>
+      <p:sp>
+        <p:nvSpPr>
+          <p:cNvPr id="9" name="Text 7"/>
+          <p:cNvSpPr txBox="1"/>
+          <p:nvPr/>
+        </p:nvSpPr>
+        <p:spPr>
+          <a:xfrm>
+            <a:off x="1261872" y="1709928"/>
+            <a:ext cx="9966960" cy="292608"/>
+          </a:xfrm>
+          <a:prstGeom prst="rect">
+            <a:avLst/>
+          </a:prstGeom>
+          <a:noFill/>
+          <a:ln/>
+        </p:spPr>
+        <p:txBody>
+          <a:bodyPr wrap="square" lIns="0" tIns="0" rIns="0" bIns="0" rtlCol="0" anchor="ctr"/>
+          <a:lstStyle/>
+          <a:p>
+            <a:pPr indent="0" marL="0">
+              <a:buNone/>
+            </a:pPr>
+            <a:r>
               <a:rPr lang="en-US" sz="1400" b="1" dirty="0">
                 <a:solidFill>
-                  <a:srgbClr val="FFFFFF"/>
-                </a:solidFill>
-                <a:latin typeface="Calibri" pitchFamily="34" charset="0"/>
-                <a:ea typeface="Calibri" pitchFamily="34" charset="-122"/>
-                <a:cs typeface="Calibri" pitchFamily="34" charset="-120"/>
-              </a:rPr>
-              <a:t>2</a:t>
+                  <a:srgbClr val="1F1E1D"/>
+                </a:solidFill>
+                <a:latin typeface="Calibri" pitchFamily="34" charset="0"/>
+                <a:ea typeface="Calibri" pitchFamily="34" charset="-122"/>
+                <a:cs typeface="Calibri" pitchFamily="34" charset="-120"/>
+              </a:rPr>
+              <a:t>公式Quickstart &amp; CLAUDE.md/自動メモリ</a:t>
             </a:r>
             <a:endParaRPr lang="en-US" sz="1400" dirty="0"/>
           </a:p>
@@ -10810,69 +10938,30 @@
       </p:sp>
       <p:sp>
         <p:nvSpPr>
-          <p:cNvPr id="9" name="Text 7"/>
-          <p:cNvSpPr txBox="1"/>
-          <p:nvPr/>
-        </p:nvSpPr>
-        <p:spPr>
-          <a:xfrm>
-            <a:off x="1298448" y="1920240"/>
-            <a:ext cx="9875520" cy="320040"/>
-          </a:xfrm>
-          <a:prstGeom prst="rect">
-            <a:avLst/>
-          </a:prstGeom>
-          <a:noFill/>
-          <a:ln/>
-        </p:spPr>
-        <p:txBody>
-          <a:bodyPr wrap="square" lIns="0" tIns="0" rIns="0" bIns="0" rtlCol="0" anchor="ctr"/>
-          <a:lstStyle/>
-          <a:p>
-            <a:pPr indent="0" marL="0">
-              <a:buNone/>
-            </a:pPr>
-            <a:r>
-              <a:rPr lang="en-US" sz="1500" b="1" dirty="0">
-                <a:solidFill>
-                  <a:srgbClr val="1F1E1D"/>
-                </a:solidFill>
-                <a:latin typeface="Calibri" pitchFamily="34" charset="0"/>
-                <a:ea typeface="Calibri" pitchFamily="34" charset="-122"/>
-                <a:cs typeface="Calibri" pitchFamily="34" charset="-120"/>
-              </a:rPr>
-              <a:t>公式Quickstart &amp; CLAUDE.md/自動メモリ</a:t>
-            </a:r>
-            <a:endParaRPr lang="en-US" sz="1500" dirty="0"/>
-          </a:p>
-        </p:txBody>
-      </p:sp>
-      <p:sp>
-        <p:nvSpPr>
           <p:cNvPr id="10" name="Text 8"/>
           <p:cNvSpPr txBox="1"/>
           <p:nvPr/>
         </p:nvSpPr>
         <p:spPr>
           <a:xfrm>
-            <a:off x="1298448" y="2221992"/>
-            <a:ext cx="9875520" cy="320040"/>
-          </a:xfrm>
-          <a:prstGeom prst="rect">
-            <a:avLst/>
-          </a:prstGeom>
-          <a:noFill/>
-          <a:ln/>
-        </p:spPr>
-        <p:txBody>
-          <a:bodyPr wrap="square" lIns="0" tIns="0" rIns="0" bIns="0" rtlCol="0" anchor="ctr"/>
-          <a:lstStyle/>
-          <a:p>
-            <a:pPr indent="0" marL="0">
-              <a:buNone/>
-            </a:pPr>
-            <a:r>
-              <a:rPr lang="en-US" sz="1100" dirty="0">
+            <a:off x="1261872" y="1984248"/>
+            <a:ext cx="9966960" cy="292608"/>
+          </a:xfrm>
+          <a:prstGeom prst="rect">
+            <a:avLst/>
+          </a:prstGeom>
+          <a:noFill/>
+          <a:ln/>
+        </p:spPr>
+        <p:txBody>
+          <a:bodyPr wrap="square" lIns="0" tIns="0" rIns="0" bIns="0" rtlCol="0" anchor="ctr"/>
+          <a:lstStyle/>
+          <a:p>
+            <a:pPr indent="0" marL="0">
+              <a:buNone/>
+            </a:pPr>
+            <a:r>
+              <a:rPr lang="en-US" sz="1050" dirty="0">
                 <a:solidFill>
                   <a:srgbClr val="6B6862"/>
                 </a:solidFill>
@@ -10882,7 +10971,7 @@
               </a:rPr>
               <a:t>インストール〜基本コマンド〜プロジェクトの記憶の仕組み</a:t>
             </a:r>
-            <a:endParaRPr lang="en-US" sz="1100" dirty="0"/>
+            <a:endParaRPr lang="en-US" sz="1050" dirty="0"/>
           </a:p>
         </p:txBody>
       </p:sp>
@@ -10894,8 +10983,8 @@
         </p:nvSpPr>
         <p:spPr>
           <a:xfrm>
-            <a:off x="640080" y="2706624"/>
-            <a:ext cx="438912" cy="438912"/>
+            <a:off x="640080" y="2423160"/>
+            <a:ext cx="402336" cy="402336"/>
           </a:xfrm>
           <a:prstGeom prst="ellipse">
             <a:avLst/>
@@ -10914,8 +11003,8 @@
         </p:nvSpPr>
         <p:spPr>
           <a:xfrm>
-            <a:off x="640080" y="2706624"/>
-            <a:ext cx="438912" cy="438912"/>
+            <a:off x="640080" y="2423160"/>
+            <a:ext cx="402336" cy="402336"/>
           </a:xfrm>
           <a:prstGeom prst="rect">
             <a:avLst/>
@@ -10931,15 +11020,54 @@
               <a:buNone/>
             </a:pPr>
             <a:r>
+              <a:rPr lang="en-US" sz="1300" b="1" dirty="0">
+                <a:solidFill>
+                  <a:srgbClr val="FFFFFF"/>
+                </a:solidFill>
+                <a:latin typeface="Calibri" pitchFamily="34" charset="0"/>
+                <a:ea typeface="Calibri" pitchFamily="34" charset="-122"/>
+                <a:cs typeface="Calibri" pitchFamily="34" charset="-120"/>
+              </a:rPr>
+              <a:t>3</a:t>
+            </a:r>
+            <a:endParaRPr lang="en-US" sz="1300" dirty="0"/>
+          </a:p>
+        </p:txBody>
+      </p:sp>
+      <p:sp>
+        <p:nvSpPr>
+          <p:cNvPr id="13" name="Text 11"/>
+          <p:cNvSpPr txBox="1"/>
+          <p:nvPr/>
+        </p:nvSpPr>
+        <p:spPr>
+          <a:xfrm>
+            <a:off x="1261872" y="2395728"/>
+            <a:ext cx="9966960" cy="292608"/>
+          </a:xfrm>
+          <a:prstGeom prst="rect">
+            <a:avLst/>
+          </a:prstGeom>
+          <a:noFill/>
+          <a:ln/>
+        </p:spPr>
+        <p:txBody>
+          <a:bodyPr wrap="square" lIns="0" tIns="0" rIns="0" bIns="0" rtlCol="0" anchor="ctr"/>
+          <a:lstStyle/>
+          <a:p>
+            <a:pPr indent="0" marL="0">
+              <a:buNone/>
+            </a:pPr>
+            <a:r>
               <a:rPr lang="en-US" sz="1400" b="1" dirty="0">
                 <a:solidFill>
-                  <a:srgbClr val="FFFFFF"/>
-                </a:solidFill>
-                <a:latin typeface="Calibri" pitchFamily="34" charset="0"/>
-                <a:ea typeface="Calibri" pitchFamily="34" charset="-122"/>
-                <a:cs typeface="Calibri" pitchFamily="34" charset="-120"/>
-              </a:rPr>
-              <a:t>3</a:t>
+                  <a:srgbClr val="1F1E1D"/>
+                </a:solidFill>
+                <a:latin typeface="Calibri" pitchFamily="34" charset="0"/>
+                <a:ea typeface="Calibri" pitchFamily="34" charset="-122"/>
+                <a:cs typeface="Calibri" pitchFamily="34" charset="-120"/>
+              </a:rPr>
+              <a:t>Claude Camp: Getting Started with Claude Code</a:t>
             </a:r>
             <a:endParaRPr lang="en-US" sz="1400" dirty="0"/>
           </a:p>
@@ -10947,69 +11075,30 @@
       </p:sp>
       <p:sp>
         <p:nvSpPr>
-          <p:cNvPr id="13" name="Text 11"/>
-          <p:cNvSpPr txBox="1"/>
-          <p:nvPr/>
-        </p:nvSpPr>
-        <p:spPr>
-          <a:xfrm>
-            <a:off x="1298448" y="2679192"/>
-            <a:ext cx="9875520" cy="320040"/>
-          </a:xfrm>
-          <a:prstGeom prst="rect">
-            <a:avLst/>
-          </a:prstGeom>
-          <a:noFill/>
-          <a:ln/>
-        </p:spPr>
-        <p:txBody>
-          <a:bodyPr wrap="square" lIns="0" tIns="0" rIns="0" bIns="0" rtlCol="0" anchor="ctr"/>
-          <a:lstStyle/>
-          <a:p>
-            <a:pPr indent="0" marL="0">
-              <a:buNone/>
-            </a:pPr>
-            <a:r>
-              <a:rPr lang="en-US" sz="1500" b="1" dirty="0">
-                <a:solidFill>
-                  <a:srgbClr val="1F1E1D"/>
-                </a:solidFill>
-                <a:latin typeface="Calibri" pitchFamily="34" charset="0"/>
-                <a:ea typeface="Calibri" pitchFamily="34" charset="-122"/>
-                <a:cs typeface="Calibri" pitchFamily="34" charset="-120"/>
-              </a:rPr>
-              <a:t>Claude Camp: Getting Started with Claude Code</a:t>
-            </a:r>
-            <a:endParaRPr lang="en-US" sz="1500" dirty="0"/>
-          </a:p>
-        </p:txBody>
-      </p:sp>
-      <p:sp>
-        <p:nvSpPr>
           <p:cNvPr id="14" name="Text 12"/>
           <p:cNvSpPr txBox="1"/>
           <p:nvPr/>
         </p:nvSpPr>
         <p:spPr>
           <a:xfrm>
-            <a:off x="1298448" y="2980944"/>
-            <a:ext cx="9875520" cy="320040"/>
-          </a:xfrm>
-          <a:prstGeom prst="rect">
-            <a:avLst/>
-          </a:prstGeom>
-          <a:noFill/>
-          <a:ln/>
-        </p:spPr>
-        <p:txBody>
-          <a:bodyPr wrap="square" lIns="0" tIns="0" rIns="0" bIns="0" rtlCol="0" anchor="ctr"/>
-          <a:lstStyle/>
-          <a:p>
-            <a:pPr indent="0" marL="0">
-              <a:buNone/>
-            </a:pPr>
-            <a:r>
-              <a:rPr lang="en-US" sz="1100" dirty="0">
+            <a:off x="1261872" y="2670048"/>
+            <a:ext cx="9966960" cy="292608"/>
+          </a:xfrm>
+          <a:prstGeom prst="rect">
+            <a:avLst/>
+          </a:prstGeom>
+          <a:noFill/>
+          <a:ln/>
+        </p:spPr>
+        <p:txBody>
+          <a:bodyPr wrap="square" lIns="0" tIns="0" rIns="0" bIns="0" rtlCol="0" anchor="ctr"/>
+          <a:lstStyle/>
+          <a:p>
+            <a:pPr indent="0" marL="0">
+              <a:buNone/>
+            </a:pPr>
+            <a:r>
+              <a:rPr lang="en-US" sz="1050" dirty="0">
                 <a:solidFill>
                   <a:srgbClr val="6B6862"/>
                 </a:solidFill>
@@ -11019,7 +11108,7 @@
               </a:rPr>
               <a:t>エージェントの仕組み・ワークフロー実践</a:t>
             </a:r>
-            <a:endParaRPr lang="en-US" sz="1100" dirty="0"/>
+            <a:endParaRPr lang="en-US" sz="1050" dirty="0"/>
           </a:p>
         </p:txBody>
       </p:sp>
@@ -11031,8 +11120,8 @@
         </p:nvSpPr>
         <p:spPr>
           <a:xfrm>
-            <a:off x="640080" y="3465576"/>
-            <a:ext cx="438912" cy="438912"/>
+            <a:off x="640080" y="3108960"/>
+            <a:ext cx="402336" cy="402336"/>
           </a:xfrm>
           <a:prstGeom prst="ellipse">
             <a:avLst/>
@@ -11051,8 +11140,8 @@
         </p:nvSpPr>
         <p:spPr>
           <a:xfrm>
-            <a:off x="640080" y="3465576"/>
-            <a:ext cx="438912" cy="438912"/>
+            <a:off x="640080" y="3108960"/>
+            <a:ext cx="402336" cy="402336"/>
           </a:xfrm>
           <a:prstGeom prst="rect">
             <a:avLst/>
@@ -11068,15 +11157,54 @@
               <a:buNone/>
             </a:pPr>
             <a:r>
+              <a:rPr lang="en-US" sz="1300" b="1" dirty="0">
+                <a:solidFill>
+                  <a:srgbClr val="FFFFFF"/>
+                </a:solidFill>
+                <a:latin typeface="Calibri" pitchFamily="34" charset="0"/>
+                <a:ea typeface="Calibri" pitchFamily="34" charset="-122"/>
+                <a:cs typeface="Calibri" pitchFamily="34" charset="-120"/>
+              </a:rPr>
+              <a:t>4</a:t>
+            </a:r>
+            <a:endParaRPr lang="en-US" sz="1300" dirty="0"/>
+          </a:p>
+        </p:txBody>
+      </p:sp>
+      <p:sp>
+        <p:nvSpPr>
+          <p:cNvPr id="17" name="Text 15"/>
+          <p:cNvSpPr txBox="1"/>
+          <p:nvPr/>
+        </p:nvSpPr>
+        <p:spPr>
+          <a:xfrm>
+            <a:off x="1261872" y="3081528"/>
+            <a:ext cx="9966960" cy="292608"/>
+          </a:xfrm>
+          <a:prstGeom prst="rect">
+            <a:avLst/>
+          </a:prstGeom>
+          <a:noFill/>
+          <a:ln/>
+        </p:spPr>
+        <p:txBody>
+          <a:bodyPr wrap="square" lIns="0" tIns="0" rIns="0" bIns="0" rtlCol="0" anchor="ctr"/>
+          <a:lstStyle/>
+          <a:p>
+            <a:pPr indent="0" marL="0">
+              <a:buNone/>
+            </a:pPr>
+            <a:r>
               <a:rPr lang="en-US" sz="1400" b="1" dirty="0">
                 <a:solidFill>
-                  <a:srgbClr val="FFFFFF"/>
-                </a:solidFill>
-                <a:latin typeface="Calibri" pitchFamily="34" charset="0"/>
-                <a:ea typeface="Calibri" pitchFamily="34" charset="-122"/>
-                <a:cs typeface="Calibri" pitchFamily="34" charset="-120"/>
-              </a:rPr>
-              <a:t>4</a:t>
+                  <a:srgbClr val="1F1E1D"/>
+                </a:solidFill>
+                <a:latin typeface="Calibri" pitchFamily="34" charset="0"/>
+                <a:ea typeface="Calibri" pitchFamily="34" charset="-122"/>
+                <a:cs typeface="Calibri" pitchFamily="34" charset="-120"/>
+              </a:rPr>
+              <a:t>Claude Camp: Moving to the Frontier</a:t>
             </a:r>
             <a:endParaRPr lang="en-US" sz="1400" dirty="0"/>
           </a:p>
@@ -11084,69 +11212,30 @@
       </p:sp>
       <p:sp>
         <p:nvSpPr>
-          <p:cNvPr id="17" name="Text 15"/>
-          <p:cNvSpPr txBox="1"/>
-          <p:nvPr/>
-        </p:nvSpPr>
-        <p:spPr>
-          <a:xfrm>
-            <a:off x="1298448" y="3438144"/>
-            <a:ext cx="9875520" cy="320040"/>
-          </a:xfrm>
-          <a:prstGeom prst="rect">
-            <a:avLst/>
-          </a:prstGeom>
-          <a:noFill/>
-          <a:ln/>
-        </p:spPr>
-        <p:txBody>
-          <a:bodyPr wrap="square" lIns="0" tIns="0" rIns="0" bIns="0" rtlCol="0" anchor="ctr"/>
-          <a:lstStyle/>
-          <a:p>
-            <a:pPr indent="0" marL="0">
-              <a:buNone/>
-            </a:pPr>
-            <a:r>
-              <a:rPr lang="en-US" sz="1500" b="1" dirty="0">
-                <a:solidFill>
-                  <a:srgbClr val="1F1E1D"/>
-                </a:solidFill>
-                <a:latin typeface="Calibri" pitchFamily="34" charset="0"/>
-                <a:ea typeface="Calibri" pitchFamily="34" charset="-122"/>
-                <a:cs typeface="Calibri" pitchFamily="34" charset="-120"/>
-              </a:rPr>
-              <a:t>Claude Camp: Moving to the Frontier</a:t>
-            </a:r>
-            <a:endParaRPr lang="en-US" sz="1500" dirty="0"/>
-          </a:p>
-        </p:txBody>
-      </p:sp>
-      <p:sp>
-        <p:nvSpPr>
           <p:cNvPr id="18" name="Text 16"/>
           <p:cNvSpPr txBox="1"/>
           <p:nvPr/>
         </p:nvSpPr>
         <p:spPr>
           <a:xfrm>
-            <a:off x="1298448" y="3739896"/>
-            <a:ext cx="9875520" cy="320040"/>
-          </a:xfrm>
-          <a:prstGeom prst="rect">
-            <a:avLst/>
-          </a:prstGeom>
-          <a:noFill/>
-          <a:ln/>
-        </p:spPr>
-        <p:txBody>
-          <a:bodyPr wrap="square" lIns="0" tIns="0" rIns="0" bIns="0" rtlCol="0" anchor="ctr"/>
-          <a:lstStyle/>
-          <a:p>
-            <a:pPr indent="0" marL="0">
-              <a:buNone/>
-            </a:pPr>
-            <a:r>
-              <a:rPr lang="en-US" sz="1100" dirty="0">
+            <a:off x="1261872" y="3355848"/>
+            <a:ext cx="9966960" cy="292608"/>
+          </a:xfrm>
+          <a:prstGeom prst="rect">
+            <a:avLst/>
+          </a:prstGeom>
+          <a:noFill/>
+          <a:ln/>
+        </p:spPr>
+        <p:txBody>
+          <a:bodyPr wrap="square" lIns="0" tIns="0" rIns="0" bIns="0" rtlCol="0" anchor="ctr"/>
+          <a:lstStyle/>
+          <a:p>
+            <a:pPr indent="0" marL="0">
+              <a:buNone/>
+            </a:pPr>
+            <a:r>
+              <a:rPr lang="en-US" sz="1050" dirty="0">
                 <a:solidFill>
                   <a:srgbClr val="6B6862"/>
                 </a:solidFill>
@@ -11156,7 +11245,7 @@
               </a:rPr>
               <a:t>AI進歩トレンドとビジネス戦略</a:t>
             </a:r>
-            <a:endParaRPr lang="en-US" sz="1100" dirty="0"/>
+            <a:endParaRPr lang="en-US" sz="1050" dirty="0"/>
           </a:p>
         </p:txBody>
       </p:sp>
@@ -11168,8 +11257,8 @@
         </p:nvSpPr>
         <p:spPr>
           <a:xfrm>
-            <a:off x="640080" y="4224528"/>
-            <a:ext cx="438912" cy="438912"/>
+            <a:off x="640080" y="3794760"/>
+            <a:ext cx="402336" cy="402336"/>
           </a:xfrm>
           <a:prstGeom prst="ellipse">
             <a:avLst/>
@@ -11188,8 +11277,8 @@
         </p:nvSpPr>
         <p:spPr>
           <a:xfrm>
-            <a:off x="640080" y="4224528"/>
-            <a:ext cx="438912" cy="438912"/>
+            <a:off x="640080" y="3794760"/>
+            <a:ext cx="402336" cy="402336"/>
           </a:xfrm>
           <a:prstGeom prst="rect">
             <a:avLst/>
@@ -11205,15 +11294,54 @@
               <a:buNone/>
             </a:pPr>
             <a:r>
+              <a:rPr lang="en-US" sz="1300" b="1" dirty="0">
+                <a:solidFill>
+                  <a:srgbClr val="FFFFFF"/>
+                </a:solidFill>
+                <a:latin typeface="Calibri" pitchFamily="34" charset="0"/>
+                <a:ea typeface="Calibri" pitchFamily="34" charset="-122"/>
+                <a:cs typeface="Calibri" pitchFamily="34" charset="-120"/>
+              </a:rPr>
+              <a:t>5</a:t>
+            </a:r>
+            <a:endParaRPr lang="en-US" sz="1300" dirty="0"/>
+          </a:p>
+        </p:txBody>
+      </p:sp>
+      <p:sp>
+        <p:nvSpPr>
+          <p:cNvPr id="21" name="Text 19"/>
+          <p:cNvSpPr txBox="1"/>
+          <p:nvPr/>
+        </p:nvSpPr>
+        <p:spPr>
+          <a:xfrm>
+            <a:off x="1261872" y="3767328"/>
+            <a:ext cx="9966960" cy="292608"/>
+          </a:xfrm>
+          <a:prstGeom prst="rect">
+            <a:avLst/>
+          </a:prstGeom>
+          <a:noFill/>
+          <a:ln/>
+        </p:spPr>
+        <p:txBody>
+          <a:bodyPr wrap="square" lIns="0" tIns="0" rIns="0" bIns="0" rtlCol="0" anchor="ctr"/>
+          <a:lstStyle/>
+          <a:p>
+            <a:pPr indent="0" marL="0">
+              <a:buNone/>
+            </a:pPr>
+            <a:r>
               <a:rPr lang="en-US" sz="1400" b="1" dirty="0">
                 <a:solidFill>
-                  <a:srgbClr val="FFFFFF"/>
-                </a:solidFill>
-                <a:latin typeface="Calibri" pitchFamily="34" charset="0"/>
-                <a:ea typeface="Calibri" pitchFamily="34" charset="-122"/>
-                <a:cs typeface="Calibri" pitchFamily="34" charset="-120"/>
-              </a:rPr>
-              <a:t>5</a:t>
+                  <a:srgbClr val="1F1E1D"/>
+                </a:solidFill>
+                <a:latin typeface="Calibri" pitchFamily="34" charset="0"/>
+                <a:ea typeface="Calibri" pitchFamily="34" charset="-122"/>
+                <a:cs typeface="Calibri" pitchFamily="34" charset="-120"/>
+              </a:rPr>
+              <a:t>Claude Camp: Proving value and controlling cost</a:t>
             </a:r>
             <a:endParaRPr lang="en-US" sz="1400" dirty="0"/>
           </a:p>
@@ -11221,69 +11349,30 @@
       </p:sp>
       <p:sp>
         <p:nvSpPr>
-          <p:cNvPr id="21" name="Text 19"/>
-          <p:cNvSpPr txBox="1"/>
-          <p:nvPr/>
-        </p:nvSpPr>
-        <p:spPr>
-          <a:xfrm>
-            <a:off x="1298448" y="4197096"/>
-            <a:ext cx="9875520" cy="320040"/>
-          </a:xfrm>
-          <a:prstGeom prst="rect">
-            <a:avLst/>
-          </a:prstGeom>
-          <a:noFill/>
-          <a:ln/>
-        </p:spPr>
-        <p:txBody>
-          <a:bodyPr wrap="square" lIns="0" tIns="0" rIns="0" bIns="0" rtlCol="0" anchor="ctr"/>
-          <a:lstStyle/>
-          <a:p>
-            <a:pPr indent="0" marL="0">
-              <a:buNone/>
-            </a:pPr>
-            <a:r>
-              <a:rPr lang="en-US" sz="1500" b="1" dirty="0">
-                <a:solidFill>
-                  <a:srgbClr val="1F1E1D"/>
-                </a:solidFill>
-                <a:latin typeface="Calibri" pitchFamily="34" charset="0"/>
-                <a:ea typeface="Calibri" pitchFamily="34" charset="-122"/>
-                <a:cs typeface="Calibri" pitchFamily="34" charset="-120"/>
-              </a:rPr>
-              <a:t>Claude Camp: Proving value and controlling cost</a:t>
-            </a:r>
-            <a:endParaRPr lang="en-US" sz="1500" dirty="0"/>
-          </a:p>
-        </p:txBody>
-      </p:sp>
-      <p:sp>
-        <p:nvSpPr>
           <p:cNvPr id="22" name="Text 20"/>
           <p:cNvSpPr txBox="1"/>
           <p:nvPr/>
         </p:nvSpPr>
         <p:spPr>
           <a:xfrm>
-            <a:off x="1298448" y="4498848"/>
-            <a:ext cx="9875520" cy="320040"/>
-          </a:xfrm>
-          <a:prstGeom prst="rect">
-            <a:avLst/>
-          </a:prstGeom>
-          <a:noFill/>
-          <a:ln/>
-        </p:spPr>
-        <p:txBody>
-          <a:bodyPr wrap="square" lIns="0" tIns="0" rIns="0" bIns="0" rtlCol="0" anchor="ctr"/>
-          <a:lstStyle/>
-          <a:p>
-            <a:pPr indent="0" marL="0">
-              <a:buNone/>
-            </a:pPr>
-            <a:r>
-              <a:rPr lang="en-US" sz="1100" dirty="0">
+            <a:off x="1261872" y="4041648"/>
+            <a:ext cx="9966960" cy="292608"/>
+          </a:xfrm>
+          <a:prstGeom prst="rect">
+            <a:avLst/>
+          </a:prstGeom>
+          <a:noFill/>
+          <a:ln/>
+        </p:spPr>
+        <p:txBody>
+          <a:bodyPr wrap="square" lIns="0" tIns="0" rIns="0" bIns="0" rtlCol="0" anchor="ctr"/>
+          <a:lstStyle/>
+          <a:p>
+            <a:pPr indent="0" marL="0">
+              <a:buNone/>
+            </a:pPr>
+            <a:r>
+              <a:rPr lang="en-US" sz="1050" dirty="0">
                 <a:solidFill>
                   <a:srgbClr val="6B6862"/>
                 </a:solidFill>
@@ -11293,7 +11382,7 @@
               </a:rPr>
               <a:t>コスト管理と価値実現の実例</a:t>
             </a:r>
-            <a:endParaRPr lang="en-US" sz="1100" dirty="0"/>
+            <a:endParaRPr lang="en-US" sz="1050" dirty="0"/>
           </a:p>
         </p:txBody>
       </p:sp>
@@ -11305,8 +11394,8 @@
         </p:nvSpPr>
         <p:spPr>
           <a:xfrm>
-            <a:off x="640080" y="4983480"/>
-            <a:ext cx="438912" cy="438912"/>
+            <a:off x="640080" y="4480560"/>
+            <a:ext cx="402336" cy="402336"/>
           </a:xfrm>
           <a:prstGeom prst="ellipse">
             <a:avLst/>
@@ -11325,8 +11414,8 @@
         </p:nvSpPr>
         <p:spPr>
           <a:xfrm>
-            <a:off x="640080" y="4983480"/>
-            <a:ext cx="438912" cy="438912"/>
+            <a:off x="640080" y="4480560"/>
+            <a:ext cx="402336" cy="402336"/>
           </a:xfrm>
           <a:prstGeom prst="rect">
             <a:avLst/>
@@ -11342,15 +11431,54 @@
               <a:buNone/>
             </a:pPr>
             <a:r>
+              <a:rPr lang="en-US" sz="1300" b="1" dirty="0">
+                <a:solidFill>
+                  <a:srgbClr val="FFFFFF"/>
+                </a:solidFill>
+                <a:latin typeface="Calibri" pitchFamily="34" charset="0"/>
+                <a:ea typeface="Calibri" pitchFamily="34" charset="-122"/>
+                <a:cs typeface="Calibri" pitchFamily="34" charset="-120"/>
+              </a:rPr>
+              <a:t>6</a:t>
+            </a:r>
+            <a:endParaRPr lang="en-US" sz="1300" dirty="0"/>
+          </a:p>
+        </p:txBody>
+      </p:sp>
+      <p:sp>
+        <p:nvSpPr>
+          <p:cNvPr id="25" name="Text 23"/>
+          <p:cNvSpPr txBox="1"/>
+          <p:nvPr/>
+        </p:nvSpPr>
+        <p:spPr>
+          <a:xfrm>
+            <a:off x="1261872" y="4453128"/>
+            <a:ext cx="9966960" cy="292608"/>
+          </a:xfrm>
+          <a:prstGeom prst="rect">
+            <a:avLst/>
+          </a:prstGeom>
+          <a:noFill/>
+          <a:ln/>
+        </p:spPr>
+        <p:txBody>
+          <a:bodyPr wrap="square" lIns="0" tIns="0" rIns="0" bIns="0" rtlCol="0" anchor="ctr"/>
+          <a:lstStyle/>
+          <a:p>
+            <a:pPr indent="0" marL="0">
+              <a:buNone/>
+            </a:pPr>
+            <a:r>
               <a:rPr lang="en-US" sz="1400" b="1" dirty="0">
                 <a:solidFill>
-                  <a:srgbClr val="FFFFFF"/>
-                </a:solidFill>
-                <a:latin typeface="Calibri" pitchFamily="34" charset="0"/>
-                <a:ea typeface="Calibri" pitchFamily="34" charset="-122"/>
-                <a:cs typeface="Calibri" pitchFamily="34" charset="-120"/>
-              </a:rPr>
-              <a:t>6</a:t>
+                  <a:srgbClr val="1F1E1D"/>
+                </a:solidFill>
+                <a:latin typeface="Calibri" pitchFamily="34" charset="0"/>
+                <a:ea typeface="Calibri" pitchFamily="34" charset="-122"/>
+                <a:cs typeface="Calibri" pitchFamily="34" charset="-120"/>
+              </a:rPr>
+              <a:t>Claude Camp: AI Fluency</a:t>
             </a:r>
             <a:endParaRPr lang="en-US" sz="1400" dirty="0"/>
           </a:p>
@@ -11358,69 +11486,30 @@
       </p:sp>
       <p:sp>
         <p:nvSpPr>
-          <p:cNvPr id="25" name="Text 23"/>
-          <p:cNvSpPr txBox="1"/>
-          <p:nvPr/>
-        </p:nvSpPr>
-        <p:spPr>
-          <a:xfrm>
-            <a:off x="1298448" y="4956048"/>
-            <a:ext cx="9875520" cy="320040"/>
-          </a:xfrm>
-          <a:prstGeom prst="rect">
-            <a:avLst/>
-          </a:prstGeom>
-          <a:noFill/>
-          <a:ln/>
-        </p:spPr>
-        <p:txBody>
-          <a:bodyPr wrap="square" lIns="0" tIns="0" rIns="0" bIns="0" rtlCol="0" anchor="ctr"/>
-          <a:lstStyle/>
-          <a:p>
-            <a:pPr indent="0" marL="0">
-              <a:buNone/>
-            </a:pPr>
-            <a:r>
-              <a:rPr lang="en-US" sz="1500" b="1" dirty="0">
-                <a:solidFill>
-                  <a:srgbClr val="1F1E1D"/>
-                </a:solidFill>
-                <a:latin typeface="Calibri" pitchFamily="34" charset="0"/>
-                <a:ea typeface="Calibri" pitchFamily="34" charset="-122"/>
-                <a:cs typeface="Calibri" pitchFamily="34" charset="-120"/>
-              </a:rPr>
-              <a:t>Claude Camp: AI Fluency</a:t>
-            </a:r>
-            <a:endParaRPr lang="en-US" sz="1500" dirty="0"/>
-          </a:p>
-        </p:txBody>
-      </p:sp>
-      <p:sp>
-        <p:nvSpPr>
           <p:cNvPr id="26" name="Text 24"/>
           <p:cNvSpPr txBox="1"/>
           <p:nvPr/>
         </p:nvSpPr>
         <p:spPr>
           <a:xfrm>
-            <a:off x="1298448" y="5257800"/>
-            <a:ext cx="9875520" cy="320040"/>
-          </a:xfrm>
-          <a:prstGeom prst="rect">
-            <a:avLst/>
-          </a:prstGeom>
-          <a:noFill/>
-          <a:ln/>
-        </p:spPr>
-        <p:txBody>
-          <a:bodyPr wrap="square" lIns="0" tIns="0" rIns="0" bIns="0" rtlCol="0" anchor="ctr"/>
-          <a:lstStyle/>
-          <a:p>
-            <a:pPr indent="0" marL="0">
-              <a:buNone/>
-            </a:pPr>
-            <a:r>
-              <a:rPr lang="en-US" sz="1100" dirty="0">
+            <a:off x="1261872" y="4727448"/>
+            <a:ext cx="9966960" cy="292608"/>
+          </a:xfrm>
+          <a:prstGeom prst="rect">
+            <a:avLst/>
+          </a:prstGeom>
+          <a:noFill/>
+          <a:ln/>
+        </p:spPr>
+        <p:txBody>
+          <a:bodyPr wrap="square" lIns="0" tIns="0" rIns="0" bIns="0" rtlCol="0" anchor="ctr"/>
+          <a:lstStyle/>
+          <a:p>
+            <a:pPr indent="0" marL="0">
+              <a:buNone/>
+            </a:pPr>
+            <a:r>
+              <a:rPr lang="en-US" sz="1050" dirty="0">
                 <a:solidFill>
                   <a:srgbClr val="6B6862"/>
                 </a:solidFill>
@@ -11430,7 +11519,7 @@
               </a:rPr>
               <a:t>4Dフレームワークと組織への浸透</a:t>
             </a:r>
-            <a:endParaRPr lang="en-US" sz="1100" dirty="0"/>
+            <a:endParaRPr lang="en-US" sz="1050" dirty="0"/>
           </a:p>
         </p:txBody>
       </p:sp>
@@ -11442,8 +11531,8 @@
         </p:nvSpPr>
         <p:spPr>
           <a:xfrm>
-            <a:off x="640080" y="5742432"/>
-            <a:ext cx="438912" cy="438912"/>
+            <a:off x="640080" y="5166360"/>
+            <a:ext cx="402336" cy="402336"/>
           </a:xfrm>
           <a:prstGeom prst="ellipse">
             <a:avLst/>
@@ -11462,8 +11551,8 @@
         </p:nvSpPr>
         <p:spPr>
           <a:xfrm>
-            <a:off x="640080" y="5742432"/>
-            <a:ext cx="438912" cy="438912"/>
+            <a:off x="640080" y="5166360"/>
+            <a:ext cx="402336" cy="402336"/>
           </a:xfrm>
           <a:prstGeom prst="rect">
             <a:avLst/>
@@ -11479,15 +11568,191 @@
               <a:buNone/>
             </a:pPr>
             <a:r>
+              <a:rPr lang="en-US" sz="1300" b="1" dirty="0">
+                <a:solidFill>
+                  <a:srgbClr val="FFFFFF"/>
+                </a:solidFill>
+                <a:latin typeface="Calibri" pitchFamily="34" charset="0"/>
+                <a:ea typeface="Calibri" pitchFamily="34" charset="-122"/>
+                <a:cs typeface="Calibri" pitchFamily="34" charset="-120"/>
+              </a:rPr>
+              <a:t>7</a:t>
+            </a:r>
+            <a:endParaRPr lang="en-US" sz="1300" dirty="0"/>
+          </a:p>
+        </p:txBody>
+      </p:sp>
+      <p:sp>
+        <p:nvSpPr>
+          <p:cNvPr id="29" name="Text 27"/>
+          <p:cNvSpPr txBox="1"/>
+          <p:nvPr/>
+        </p:nvSpPr>
+        <p:spPr>
+          <a:xfrm>
+            <a:off x="1261872" y="5138928"/>
+            <a:ext cx="9966960" cy="292608"/>
+          </a:xfrm>
+          <a:prstGeom prst="rect">
+            <a:avLst/>
+          </a:prstGeom>
+          <a:noFill/>
+          <a:ln/>
+        </p:spPr>
+        <p:txBody>
+          <a:bodyPr wrap="square" lIns="0" tIns="0" rIns="0" bIns="0" rtlCol="0" anchor="ctr"/>
+          <a:lstStyle/>
+          <a:p>
+            <a:pPr indent="0" marL="0">
+              <a:buNone/>
+            </a:pPr>
+            <a:r>
               <a:rPr lang="en-US" sz="1400" b="1" dirty="0">
                 <a:solidFill>
+                  <a:srgbClr val="1F1E1D"/>
+                </a:solidFill>
+                <a:latin typeface="Calibri" pitchFamily="34" charset="0"/>
+                <a:ea typeface="Calibri" pitchFamily="34" charset="-122"/>
+                <a:cs typeface="Calibri" pitchFamily="34" charset="-120"/>
+              </a:rPr>
+              <a:t>Claude Camp: Your first real workflow in Cowork</a:t>
+            </a:r>
+            <a:endParaRPr lang="en-US" sz="1400" dirty="0"/>
+          </a:p>
+        </p:txBody>
+      </p:sp>
+      <p:sp>
+        <p:nvSpPr>
+          <p:cNvPr id="30" name="Text 28"/>
+          <p:cNvSpPr txBox="1"/>
+          <p:nvPr/>
+        </p:nvSpPr>
+        <p:spPr>
+          <a:xfrm>
+            <a:off x="1261872" y="5413248"/>
+            <a:ext cx="9966960" cy="292608"/>
+          </a:xfrm>
+          <a:prstGeom prst="rect">
+            <a:avLst/>
+          </a:prstGeom>
+          <a:noFill/>
+          <a:ln/>
+        </p:spPr>
+        <p:txBody>
+          <a:bodyPr wrap="square" lIns="0" tIns="0" rIns="0" bIns="0" rtlCol="0" anchor="ctr"/>
+          <a:lstStyle/>
+          <a:p>
+            <a:pPr indent="0" marL="0">
+              <a:buNone/>
+            </a:pPr>
+            <a:r>
+              <a:rPr lang="en-US" sz="1050" dirty="0">
+                <a:solidFill>
+                  <a:srgbClr val="6B6862"/>
+                </a:solidFill>
+                <a:latin typeface="Calibri" pitchFamily="34" charset="0"/>
+                <a:ea typeface="Calibri" pitchFamily="34" charset="-122"/>
+                <a:cs typeface="Calibri" pitchFamily="34" charset="-120"/>
+              </a:rPr>
+              <a:t>Coworkでの実践ワークフロー構築</a:t>
+            </a:r>
+            <a:endParaRPr lang="en-US" sz="1050" dirty="0"/>
+          </a:p>
+        </p:txBody>
+      </p:sp>
+      <p:sp>
+        <p:nvSpPr>
+          <p:cNvPr id="31" name="Shape 29"/>
+          <p:cNvSpPr/>
+          <p:nvPr/>
+        </p:nvSpPr>
+        <p:spPr>
+          <a:xfrm>
+            <a:off x="640080" y="5852160"/>
+            <a:ext cx="402336" cy="402336"/>
+          </a:xfrm>
+          <a:prstGeom prst="ellipse">
+            <a:avLst/>
+          </a:prstGeom>
+          <a:solidFill>
+            <a:srgbClr val="CC785C"/>
+          </a:solidFill>
+          <a:ln/>
+        </p:spPr>
+      </p:sp>
+      <p:sp>
+        <p:nvSpPr>
+          <p:cNvPr id="32" name="Text 30"/>
+          <p:cNvSpPr txBox="1"/>
+          <p:nvPr/>
+        </p:nvSpPr>
+        <p:spPr>
+          <a:xfrm>
+            <a:off x="640080" y="5852160"/>
+            <a:ext cx="402336" cy="402336"/>
+          </a:xfrm>
+          <a:prstGeom prst="rect">
+            <a:avLst/>
+          </a:prstGeom>
+          <a:noFill/>
+          <a:ln/>
+        </p:spPr>
+        <p:txBody>
+          <a:bodyPr wrap="square" lIns="0" tIns="0" rIns="0" bIns="0" rtlCol="0" anchor="ctr"/>
+          <a:lstStyle/>
+          <a:p>
+            <a:pPr algn="ctr" indent="0" marL="0">
+              <a:buNone/>
+            </a:pPr>
+            <a:r>
+              <a:rPr lang="en-US" sz="1300" b="1" dirty="0">
+                <a:solidFill>
                   <a:srgbClr val="FFFFFF"/>
                 </a:solidFill>
                 <a:latin typeface="Calibri" pitchFamily="34" charset="0"/>
                 <a:ea typeface="Calibri" pitchFamily="34" charset="-122"/>
                 <a:cs typeface="Calibri" pitchFamily="34" charset="-120"/>
               </a:rPr>
-              <a:t>7</a:t>
+              <a:t>8</a:t>
+            </a:r>
+            <a:endParaRPr lang="en-US" sz="1300" dirty="0"/>
+          </a:p>
+        </p:txBody>
+      </p:sp>
+      <p:sp>
+        <p:nvSpPr>
+          <p:cNvPr id="33" name="Text 31"/>
+          <p:cNvSpPr txBox="1"/>
+          <p:nvPr/>
+        </p:nvSpPr>
+        <p:spPr>
+          <a:xfrm>
+            <a:off x="1261872" y="5824728"/>
+            <a:ext cx="9966960" cy="292608"/>
+          </a:xfrm>
+          <a:prstGeom prst="rect">
+            <a:avLst/>
+          </a:prstGeom>
+          <a:noFill/>
+          <a:ln/>
+        </p:spPr>
+        <p:txBody>
+          <a:bodyPr wrap="square" lIns="0" tIns="0" rIns="0" bIns="0" rtlCol="0" anchor="ctr"/>
+          <a:lstStyle/>
+          <a:p>
+            <a:pPr indent="0" marL="0">
+              <a:buNone/>
+            </a:pPr>
+            <a:r>
+              <a:rPr lang="en-US" sz="1400" b="1" dirty="0">
+                <a:solidFill>
+                  <a:srgbClr val="1F1E1D"/>
+                </a:solidFill>
+                <a:latin typeface="Calibri" pitchFamily="34" charset="0"/>
+                <a:ea typeface="Calibri" pitchFamily="34" charset="-122"/>
+                <a:cs typeface="Calibri" pitchFamily="34" charset="-120"/>
+              </a:rPr>
+              <a:t>Claude Frontier Academy</a:t>
             </a:r>
             <a:endParaRPr lang="en-US" sz="1400" dirty="0"/>
           </a:p>
@@ -11495,69 +11760,30 @@
       </p:sp>
       <p:sp>
         <p:nvSpPr>
-          <p:cNvPr id="29" name="Text 27"/>
-          <p:cNvSpPr txBox="1"/>
-          <p:nvPr/>
-        </p:nvSpPr>
-        <p:spPr>
-          <a:xfrm>
-            <a:off x="1298448" y="5715000"/>
-            <a:ext cx="9875520" cy="320040"/>
-          </a:xfrm>
-          <a:prstGeom prst="rect">
-            <a:avLst/>
-          </a:prstGeom>
-          <a:noFill/>
-          <a:ln/>
-        </p:spPr>
-        <p:txBody>
-          <a:bodyPr wrap="square" lIns="0" tIns="0" rIns="0" bIns="0" rtlCol="0" anchor="ctr"/>
-          <a:lstStyle/>
-          <a:p>
-            <a:pPr indent="0" marL="0">
-              <a:buNone/>
-            </a:pPr>
-            <a:r>
-              <a:rPr lang="en-US" sz="1500" b="1" dirty="0">
-                <a:solidFill>
-                  <a:srgbClr val="1F1E1D"/>
-                </a:solidFill>
-                <a:latin typeface="Calibri" pitchFamily="34" charset="0"/>
-                <a:ea typeface="Calibri" pitchFamily="34" charset="-122"/>
-                <a:cs typeface="Calibri" pitchFamily="34" charset="-120"/>
-              </a:rPr>
-              <a:t>Claude Camp: Your first real workflow in Cowork</a:t>
-            </a:r>
-            <a:endParaRPr lang="en-US" sz="1500" dirty="0"/>
-          </a:p>
-        </p:txBody>
-      </p:sp>
-      <p:sp>
-        <p:nvSpPr>
-          <p:cNvPr id="30" name="Text 28"/>
-          <p:cNvSpPr txBox="1"/>
-          <p:nvPr/>
-        </p:nvSpPr>
-        <p:spPr>
-          <a:xfrm>
-            <a:off x="1298448" y="6016752"/>
-            <a:ext cx="9875520" cy="320040"/>
-          </a:xfrm>
-          <a:prstGeom prst="rect">
-            <a:avLst/>
-          </a:prstGeom>
-          <a:noFill/>
-          <a:ln/>
-        </p:spPr>
-        <p:txBody>
-          <a:bodyPr wrap="square" lIns="0" tIns="0" rIns="0" bIns="0" rtlCol="0" anchor="ctr"/>
-          <a:lstStyle/>
-          <a:p>
-            <a:pPr indent="0" marL="0">
-              <a:buNone/>
-            </a:pPr>
-            <a:r>
-              <a:rPr lang="en-US" sz="1100" dirty="0">
+          <p:cNvPr id="34" name="Text 32"/>
+          <p:cNvSpPr txBox="1"/>
+          <p:nvPr/>
+        </p:nvSpPr>
+        <p:spPr>
+          <a:xfrm>
+            <a:off x="1261872" y="6099048"/>
+            <a:ext cx="9966960" cy="292608"/>
+          </a:xfrm>
+          <a:prstGeom prst="rect">
+            <a:avLst/>
+          </a:prstGeom>
+          <a:noFill/>
+          <a:ln/>
+        </p:spPr>
+        <p:txBody>
+          <a:bodyPr wrap="square" lIns="0" tIns="0" rIns="0" bIns="0" rtlCol="0" anchor="ctr"/>
+          <a:lstStyle/>
+          <a:p>
+            <a:pPr indent="0" marL="0">
+              <a:buNone/>
+            </a:pPr>
+            <a:r>
+              <a:rPr lang="en-US" sz="1050" dirty="0">
                 <a:solidFill>
                   <a:srgbClr val="6B6862"/>
                 </a:solidFill>
@@ -11565,15 +11791,15 @@
                 <a:ea typeface="Calibri" pitchFamily="34" charset="-122"/>
                 <a:cs typeface="Calibri" pitchFamily="34" charset="-120"/>
               </a:rPr>
-              <a:t>Coworkでの実践ワークフロー構築</a:t>
-            </a:r>
-            <a:endParaRPr lang="en-US" sz="1100" dirty="0"/>
-          </a:p>
-        </p:txBody>
-      </p:sp>
-      <p:sp>
-        <p:nvSpPr>
-          <p:cNvPr id="31" name="Text 29"/>
+              <a:t>企業向けAI人材育成プログラム($1億投資・FDE育成)</a:t>
+            </a:r>
+            <a:endParaRPr lang="en-US" sz="1050" dirty="0"/>
+          </a:p>
+        </p:txBody>
+      </p:sp>
+      <p:sp>
+        <p:nvSpPr>
+          <p:cNvPr id="35" name="Text 33"/>
           <p:cNvSpPr txBox="1"/>
           <p:nvPr/>
         </p:nvSpPr>
@@ -25973,33 +26199,33 @@
         <p:spPr>
           <a:xfrm>
             <a:off x="548640" y="457200"/>
-            <a:ext cx="10607040" cy="640080"/>
-          </a:xfrm>
-          <a:prstGeom prst="rect">
-            <a:avLst/>
-          </a:prstGeom>
-          <a:noFill/>
-          <a:ln/>
-        </p:spPr>
-        <p:txBody>
-          <a:bodyPr wrap="square" lIns="0" tIns="0" rIns="0" bIns="0" rtlCol="0" anchor="ctr"/>
-          <a:lstStyle/>
-          <a:p>
-            <a:pPr indent="0" marL="0">
-              <a:buNone/>
-            </a:pPr>
-            <a:r>
-              <a:rPr lang="en-US" sz="3000" b="1" dirty="0">
-                <a:solidFill>
-                  <a:srgbClr val="1F1E1D"/>
+            <a:ext cx="731520" cy="731520"/>
+          </a:xfrm>
+          <a:prstGeom prst="rect">
+            <a:avLst/>
+          </a:prstGeom>
+          <a:noFill/>
+          <a:ln/>
+        </p:spPr>
+        <p:txBody>
+          <a:bodyPr wrap="square" lIns="0" tIns="0" rIns="0" bIns="0" rtlCol="0" anchor="ctr"/>
+          <a:lstStyle/>
+          <a:p>
+            <a:pPr indent="0" marL="0">
+              <a:buNone/>
+            </a:pPr>
+            <a:r>
+              <a:rPr lang="en-US" sz="2600" b="1" dirty="0">
+                <a:solidFill>
+                  <a:srgbClr val="CC785C"/>
                 </a:solidFill>
                 <a:latin typeface="Cambria" pitchFamily="34" charset="0"/>
                 <a:ea typeface="Cambria" pitchFamily="34" charset="-122"/>
                 <a:cs typeface="Cambria" pitchFamily="34" charset="-120"/>
               </a:rPr>
-              <a:t>用語集・まとめ</a:t>
-            </a:r>
-            <a:endParaRPr lang="en-US" sz="3000" dirty="0"/>
+              <a:t>8</a:t>
+            </a:r>
+            <a:endParaRPr lang="en-US" sz="2600" dirty="0"/>
           </a:p>
         </p:txBody>
       </p:sp>
@@ -26011,24 +26237,136 @@
         </p:nvSpPr>
         <p:spPr>
           <a:xfrm>
-            <a:off x="548640" y="1280160"/>
-            <a:ext cx="3108960" cy="594360"/>
-          </a:xfrm>
-          <a:prstGeom prst="rect">
-            <a:avLst/>
-          </a:prstGeom>
-          <a:noFill/>
-          <a:ln/>
-        </p:spPr>
-        <p:txBody>
-          <a:bodyPr wrap="square" lIns="0" tIns="0" rIns="0" bIns="0" rtlCol="0" anchor="t"/>
-          <a:lstStyle/>
-          <a:p>
-            <a:pPr indent="0" marL="0">
-              <a:buNone/>
-            </a:pPr>
-            <a:r>
-              <a:rPr lang="en-US" sz="1200" b="1" dirty="0">
+            <a:off x="1280160" y="502920"/>
+            <a:ext cx="9784080" cy="640080"/>
+          </a:xfrm>
+          <a:prstGeom prst="rect">
+            <a:avLst/>
+          </a:prstGeom>
+          <a:noFill/>
+          <a:ln/>
+        </p:spPr>
+        <p:txBody>
+          <a:bodyPr wrap="square" lIns="0" tIns="0" rIns="0" bIns="0" rtlCol="0" anchor="ctr"/>
+          <a:lstStyle/>
+          <a:p>
+            <a:pPr indent="0" marL="0">
+              <a:buNone/>
+            </a:pPr>
+            <a:r>
+              <a:rPr lang="en-US" sz="2400" b="1" dirty="0">
+                <a:solidFill>
+                  <a:srgbClr val="1F1E1D"/>
+                </a:solidFill>
+                <a:latin typeface="Cambria" pitchFamily="34" charset="0"/>
+                <a:ea typeface="Cambria" pitchFamily="34" charset="-122"/>
+                <a:cs typeface="Cambria" pitchFamily="34" charset="-120"/>
+              </a:rPr>
+              <a:t>Claude Frontier Academy</a:t>
+            </a:r>
+            <a:endParaRPr lang="en-US" sz="2400" dirty="0"/>
+          </a:p>
+        </p:txBody>
+      </p:sp>
+      <p:sp>
+        <p:nvSpPr>
+          <p:cNvPr id="4" name="Text 2"/>
+          <p:cNvSpPr txBox="1"/>
+          <p:nvPr/>
+        </p:nvSpPr>
+        <p:spPr>
+          <a:xfrm>
+            <a:off x="548640" y="1371600"/>
+            <a:ext cx="10607040" cy="365760"/>
+          </a:xfrm>
+          <a:prstGeom prst="rect">
+            <a:avLst/>
+          </a:prstGeom>
+          <a:noFill/>
+          <a:ln/>
+        </p:spPr>
+        <p:txBody>
+          <a:bodyPr wrap="square" lIns="0" tIns="0" rIns="0" bIns="0" rtlCol="0" anchor="ctr"/>
+          <a:lstStyle/>
+          <a:p>
+            <a:pPr indent="0" marL="0">
+              <a:buNone/>
+            </a:pPr>
+            <a:r>
+              <a:rPr lang="en-US" sz="1250" i="1" dirty="0">
+                <a:solidFill>
+                  <a:srgbClr val="6B6862"/>
+                </a:solidFill>
+                <a:latin typeface="Calibri" pitchFamily="34" charset="0"/>
+                <a:ea typeface="Calibri" pitchFamily="34" charset="-122"/>
+                <a:cs typeface="Calibri" pitchFamily="34" charset="-120"/>
+              </a:rPr>
+              <a:t>Anthropicの企業向けAI人材育成プログラム(2025年発表)</a:t>
+            </a:r>
+            <a:endParaRPr lang="en-US" sz="1250" dirty="0"/>
+          </a:p>
+        </p:txBody>
+      </p:sp>
+      <p:sp>
+        <p:nvSpPr>
+          <p:cNvPr id="5" name="Shape 3"/>
+          <p:cNvSpPr/>
+          <p:nvPr/>
+        </p:nvSpPr>
+        <p:spPr>
+          <a:xfrm>
+            <a:off x="548640" y="1828800"/>
+            <a:ext cx="2514600" cy="1005840"/>
+          </a:xfrm>
+          <a:prstGeom prst="roundRect">
+            <a:avLst>
+              <a:gd name="adj" fmla="val 9091"/>
+            </a:avLst>
+          </a:prstGeom>
+          <a:solidFill>
+            <a:srgbClr val="FFFFFF"/>
+          </a:solidFill>
+          <a:ln w="12700">
+            <a:solidFill>
+              <a:srgbClr val="E5E2DC"/>
+            </a:solidFill>
+            <a:prstDash val="solid"/>
+          </a:ln>
+          <a:effectLst>
+            <a:outerShdw sx="100000" sy="100000" kx="0" ky="0" algn="bl" rotWithShape="0" blurRad="76200" dist="25400" dir="5400000">
+              <a:srgbClr val="000000">
+                <a:alpha val="10000"/>
+              </a:srgbClr>
+            </a:outerShdw>
+          </a:effectLst>
+        </p:spPr>
+      </p:sp>
+      <p:sp>
+        <p:nvSpPr>
+          <p:cNvPr id="6" name="Text 4"/>
+          <p:cNvSpPr txBox="1"/>
+          <p:nvPr/>
+        </p:nvSpPr>
+        <p:spPr>
+          <a:xfrm>
+            <a:off x="548640" y="1938528"/>
+            <a:ext cx="2514600" cy="502920"/>
+          </a:xfrm>
+          <a:prstGeom prst="rect">
+            <a:avLst/>
+          </a:prstGeom>
+          <a:noFill/>
+          <a:ln/>
+        </p:spPr>
+        <p:txBody>
+          <a:bodyPr wrap="square" lIns="0" tIns="0" rIns="0" bIns="0" rtlCol="0" anchor="ctr"/>
+          <a:lstStyle/>
+          <a:p>
+            <a:pPr algn="ctr" indent="0" marL="0">
+              <a:buNone/>
+            </a:pPr>
+            <a:r>
+              <a:rPr lang="en-US" sz="1900" b="1" dirty="0">
                 <a:solidFill>
                   <a:srgbClr val="CC785C"/>
                 </a:solidFill>
@@ -26036,116 +26374,657 @@
                 <a:ea typeface="Calibri" pitchFamily="34" charset="-122"/>
                 <a:cs typeface="Calibri" pitchFamily="34" charset="-120"/>
               </a:rPr>
-              <a:t>エージェントループ</a:t>
-            </a:r>
-            <a:endParaRPr lang="en-US" sz="1200" dirty="0"/>
-          </a:p>
-        </p:txBody>
-      </p:sp>
-      <p:sp>
-        <p:nvSpPr>
-          <p:cNvPr id="4" name="Text 2"/>
-          <p:cNvSpPr txBox="1"/>
-          <p:nvPr/>
-        </p:nvSpPr>
-        <p:spPr>
-          <a:xfrm>
-            <a:off x="3749040" y="1280160"/>
-            <a:ext cx="7406640" cy="594360"/>
-          </a:xfrm>
-          <a:prstGeom prst="rect">
-            <a:avLst/>
-          </a:prstGeom>
-          <a:noFill/>
-          <a:ln/>
-        </p:spPr>
-        <p:txBody>
-          <a:bodyPr wrap="square" lIns="0" tIns="0" rIns="0" bIns="0" rtlCol="0" anchor="ctr"/>
-          <a:lstStyle/>
-          <a:p>
-            <a:pPr indent="0" marL="0">
-              <a:buNone/>
+              <a:t>$1億</a:t>
+            </a:r>
+            <a:endParaRPr lang="en-US" sz="1900" dirty="0"/>
+          </a:p>
+        </p:txBody>
+      </p:sp>
+      <p:sp>
+        <p:nvSpPr>
+          <p:cNvPr id="7" name="Text 5"/>
+          <p:cNvSpPr txBox="1"/>
+          <p:nvPr/>
+        </p:nvSpPr>
+        <p:spPr>
+          <a:xfrm>
+            <a:off x="548640" y="2423160"/>
+            <a:ext cx="2514600" cy="365760"/>
+          </a:xfrm>
+          <a:prstGeom prst="rect">
+            <a:avLst/>
+          </a:prstGeom>
+          <a:noFill/>
+          <a:ln/>
+        </p:spPr>
+        <p:txBody>
+          <a:bodyPr wrap="square" lIns="0" tIns="0" rIns="0" bIns="0" rtlCol="0" anchor="ctr"/>
+          <a:lstStyle/>
+          <a:p>
+            <a:pPr algn="ctr" indent="0" marL="0">
+              <a:buNone/>
+            </a:pPr>
+            <a:r>
+              <a:rPr lang="en-US" sz="1050" dirty="0">
+                <a:solidFill>
+                  <a:srgbClr val="6B6862"/>
+                </a:solidFill>
+                <a:latin typeface="Calibri" pitchFamily="34" charset="0"/>
+                <a:ea typeface="Calibri" pitchFamily="34" charset="-122"/>
+                <a:cs typeface="Calibri" pitchFamily="34" charset="-120"/>
+              </a:rPr>
+              <a:t>投資額</a:t>
+            </a:r>
+            <a:endParaRPr lang="en-US" sz="1050" dirty="0"/>
+          </a:p>
+        </p:txBody>
+      </p:sp>
+      <p:sp>
+        <p:nvSpPr>
+          <p:cNvPr id="8" name="Shape 6"/>
+          <p:cNvSpPr/>
+          <p:nvPr/>
+        </p:nvSpPr>
+        <p:spPr>
+          <a:xfrm>
+            <a:off x="3246120" y="1828800"/>
+            <a:ext cx="2514600" cy="1005840"/>
+          </a:xfrm>
+          <a:prstGeom prst="roundRect">
+            <a:avLst>
+              <a:gd name="adj" fmla="val 9091"/>
+            </a:avLst>
+          </a:prstGeom>
+          <a:solidFill>
+            <a:srgbClr val="FFFFFF"/>
+          </a:solidFill>
+          <a:ln w="12700">
+            <a:solidFill>
+              <a:srgbClr val="E5E2DC"/>
+            </a:solidFill>
+            <a:prstDash val="solid"/>
+          </a:ln>
+          <a:effectLst>
+            <a:outerShdw sx="100000" sy="100000" kx="0" ky="0" algn="bl" rotWithShape="0" blurRad="76200" dist="25400" dir="5400000">
+              <a:srgbClr val="000000">
+                <a:alpha val="10000"/>
+              </a:srgbClr>
+            </a:outerShdw>
+          </a:effectLst>
+        </p:spPr>
+      </p:sp>
+      <p:sp>
+        <p:nvSpPr>
+          <p:cNvPr id="9" name="Text 7"/>
+          <p:cNvSpPr txBox="1"/>
+          <p:nvPr/>
+        </p:nvSpPr>
+        <p:spPr>
+          <a:xfrm>
+            <a:off x="3246120" y="1938528"/>
+            <a:ext cx="2514600" cy="502920"/>
+          </a:xfrm>
+          <a:prstGeom prst="rect">
+            <a:avLst/>
+          </a:prstGeom>
+          <a:noFill/>
+          <a:ln/>
+        </p:spPr>
+        <p:txBody>
+          <a:bodyPr wrap="square" lIns="0" tIns="0" rIns="0" bIns="0" rtlCol="0" anchor="ctr"/>
+          <a:lstStyle/>
+          <a:p>
+            <a:pPr algn="ctr" indent="0" marL="0">
+              <a:buNone/>
+            </a:pPr>
+            <a:r>
+              <a:rPr lang="en-US" sz="1900" b="1" dirty="0">
+                <a:solidFill>
+                  <a:srgbClr val="CC785C"/>
+                </a:solidFill>
+                <a:latin typeface="Calibri" pitchFamily="34" charset="0"/>
+                <a:ea typeface="Calibri" pitchFamily="34" charset="-122"/>
+                <a:cs typeface="Calibri" pitchFamily="34" charset="-120"/>
+              </a:rPr>
+              <a:t>1万人</a:t>
+            </a:r>
+            <a:endParaRPr lang="en-US" sz="1900" dirty="0"/>
+          </a:p>
+        </p:txBody>
+      </p:sp>
+      <p:sp>
+        <p:nvSpPr>
+          <p:cNvPr id="10" name="Text 8"/>
+          <p:cNvSpPr txBox="1"/>
+          <p:nvPr/>
+        </p:nvSpPr>
+        <p:spPr>
+          <a:xfrm>
+            <a:off x="3246120" y="2423160"/>
+            <a:ext cx="2514600" cy="365760"/>
+          </a:xfrm>
+          <a:prstGeom prst="rect">
+            <a:avLst/>
+          </a:prstGeom>
+          <a:noFill/>
+          <a:ln/>
+        </p:spPr>
+        <p:txBody>
+          <a:bodyPr wrap="square" lIns="0" tIns="0" rIns="0" bIns="0" rtlCol="0" anchor="ctr"/>
+          <a:lstStyle/>
+          <a:p>
+            <a:pPr algn="ctr" indent="0" marL="0">
+              <a:buNone/>
+            </a:pPr>
+            <a:r>
+              <a:rPr lang="en-US" sz="1050" dirty="0">
+                <a:solidFill>
+                  <a:srgbClr val="6B6862"/>
+                </a:solidFill>
+                <a:latin typeface="Calibri" pitchFamily="34" charset="0"/>
+                <a:ea typeface="Calibri" pitchFamily="34" charset="-122"/>
+                <a:cs typeface="Calibri" pitchFamily="34" charset="-120"/>
+              </a:rPr>
+              <a:t>2027年末までの育成目標</a:t>
+            </a:r>
+            <a:endParaRPr lang="en-US" sz="1050" dirty="0"/>
+          </a:p>
+        </p:txBody>
+      </p:sp>
+      <p:sp>
+        <p:nvSpPr>
+          <p:cNvPr id="11" name="Shape 9"/>
+          <p:cNvSpPr/>
+          <p:nvPr/>
+        </p:nvSpPr>
+        <p:spPr>
+          <a:xfrm>
+            <a:off x="5943600" y="1828800"/>
+            <a:ext cx="2514600" cy="1005840"/>
+          </a:xfrm>
+          <a:prstGeom prst="roundRect">
+            <a:avLst>
+              <a:gd name="adj" fmla="val 9091"/>
+            </a:avLst>
+          </a:prstGeom>
+          <a:solidFill>
+            <a:srgbClr val="FFFFFF"/>
+          </a:solidFill>
+          <a:ln w="12700">
+            <a:solidFill>
+              <a:srgbClr val="E5E2DC"/>
+            </a:solidFill>
+            <a:prstDash val="solid"/>
+          </a:ln>
+          <a:effectLst>
+            <a:outerShdw sx="100000" sy="100000" kx="0" ky="0" algn="bl" rotWithShape="0" blurRad="76200" dist="25400" dir="5400000">
+              <a:srgbClr val="000000">
+                <a:alpha val="10000"/>
+              </a:srgbClr>
+            </a:outerShdw>
+          </a:effectLst>
+        </p:spPr>
+      </p:sp>
+      <p:sp>
+        <p:nvSpPr>
+          <p:cNvPr id="12" name="Text 10"/>
+          <p:cNvSpPr txBox="1"/>
+          <p:nvPr/>
+        </p:nvSpPr>
+        <p:spPr>
+          <a:xfrm>
+            <a:off x="5943600" y="1938528"/>
+            <a:ext cx="2514600" cy="502920"/>
+          </a:xfrm>
+          <a:prstGeom prst="rect">
+            <a:avLst/>
+          </a:prstGeom>
+          <a:noFill/>
+          <a:ln/>
+        </p:spPr>
+        <p:txBody>
+          <a:bodyPr wrap="square" lIns="0" tIns="0" rIns="0" bIns="0" rtlCol="0" anchor="ctr"/>
+          <a:lstStyle/>
+          <a:p>
+            <a:pPr algn="ctr" indent="0" marL="0">
+              <a:buNone/>
+            </a:pPr>
+            <a:r>
+              <a:rPr lang="en-US" sz="1900" b="1" dirty="0">
+                <a:solidFill>
+                  <a:srgbClr val="CC785C"/>
+                </a:solidFill>
+                <a:latin typeface="Calibri" pitchFamily="34" charset="0"/>
+                <a:ea typeface="Calibri" pitchFamily="34" charset="-122"/>
+                <a:cs typeface="Calibri" pitchFamily="34" charset="-120"/>
+              </a:rPr>
+              <a:t>12週間</a:t>
+            </a:r>
+            <a:endParaRPr lang="en-US" sz="1900" dirty="0"/>
+          </a:p>
+        </p:txBody>
+      </p:sp>
+      <p:sp>
+        <p:nvSpPr>
+          <p:cNvPr id="13" name="Text 11"/>
+          <p:cNvSpPr txBox="1"/>
+          <p:nvPr/>
+        </p:nvSpPr>
+        <p:spPr>
+          <a:xfrm>
+            <a:off x="5943600" y="2423160"/>
+            <a:ext cx="2514600" cy="365760"/>
+          </a:xfrm>
+          <a:prstGeom prst="rect">
+            <a:avLst/>
+          </a:prstGeom>
+          <a:noFill/>
+          <a:ln/>
+        </p:spPr>
+        <p:txBody>
+          <a:bodyPr wrap="square" lIns="0" tIns="0" rIns="0" bIns="0" rtlCol="0" anchor="ctr"/>
+          <a:lstStyle/>
+          <a:p>
+            <a:pPr algn="ctr" indent="0" marL="0">
+              <a:buNone/>
+            </a:pPr>
+            <a:r>
+              <a:rPr lang="en-US" sz="1050" dirty="0">
+                <a:solidFill>
+                  <a:srgbClr val="6B6862"/>
+                </a:solidFill>
+                <a:latin typeface="Calibri" pitchFamily="34" charset="0"/>
+                <a:ea typeface="Calibri" pitchFamily="34" charset="-122"/>
+                <a:cs typeface="Calibri" pitchFamily="34" charset="-120"/>
+              </a:rPr>
+              <a:t>レジデンシー期間</a:t>
+            </a:r>
+            <a:endParaRPr lang="en-US" sz="1050" dirty="0"/>
+          </a:p>
+        </p:txBody>
+      </p:sp>
+      <p:sp>
+        <p:nvSpPr>
+          <p:cNvPr id="14" name="Shape 12"/>
+          <p:cNvSpPr/>
+          <p:nvPr/>
+        </p:nvSpPr>
+        <p:spPr>
+          <a:xfrm>
+            <a:off x="8641080" y="1828800"/>
+            <a:ext cx="2514600" cy="1005840"/>
+          </a:xfrm>
+          <a:prstGeom prst="roundRect">
+            <a:avLst>
+              <a:gd name="adj" fmla="val 9091"/>
+            </a:avLst>
+          </a:prstGeom>
+          <a:solidFill>
+            <a:srgbClr val="FFFFFF"/>
+          </a:solidFill>
+          <a:ln w="12700">
+            <a:solidFill>
+              <a:srgbClr val="E5E2DC"/>
+            </a:solidFill>
+            <a:prstDash val="solid"/>
+          </a:ln>
+          <a:effectLst>
+            <a:outerShdw sx="100000" sy="100000" kx="0" ky="0" algn="bl" rotWithShape="0" blurRad="76200" dist="25400" dir="5400000">
+              <a:srgbClr val="000000">
+                <a:alpha val="10000"/>
+              </a:srgbClr>
+            </a:outerShdw>
+          </a:effectLst>
+        </p:spPr>
+      </p:sp>
+      <p:sp>
+        <p:nvSpPr>
+          <p:cNvPr id="15" name="Text 13"/>
+          <p:cNvSpPr txBox="1"/>
+          <p:nvPr/>
+        </p:nvSpPr>
+        <p:spPr>
+          <a:xfrm>
+            <a:off x="8641080" y="1938528"/>
+            <a:ext cx="2514600" cy="502920"/>
+          </a:xfrm>
+          <a:prstGeom prst="rect">
+            <a:avLst/>
+          </a:prstGeom>
+          <a:noFill/>
+          <a:ln/>
+        </p:spPr>
+        <p:txBody>
+          <a:bodyPr wrap="square" lIns="0" tIns="0" rIns="0" bIns="0" rtlCol="0" anchor="ctr"/>
+          <a:lstStyle/>
+          <a:p>
+            <a:pPr algn="ctr" indent="0" marL="0">
+              <a:buNone/>
+            </a:pPr>
+            <a:r>
+              <a:rPr lang="en-US" sz="1900" b="1" dirty="0">
+                <a:solidFill>
+                  <a:srgbClr val="CC785C"/>
+                </a:solidFill>
+                <a:latin typeface="Calibri" pitchFamily="34" charset="0"/>
+                <a:ea typeface="Calibri" pitchFamily="34" charset="-122"/>
+                <a:cs typeface="Calibri" pitchFamily="34" charset="-120"/>
+              </a:rPr>
+              <a:t>3都市</a:t>
+            </a:r>
+            <a:endParaRPr lang="en-US" sz="1900" dirty="0"/>
+          </a:p>
+        </p:txBody>
+      </p:sp>
+      <p:sp>
+        <p:nvSpPr>
+          <p:cNvPr id="16" name="Text 14"/>
+          <p:cNvSpPr txBox="1"/>
+          <p:nvPr/>
+        </p:nvSpPr>
+        <p:spPr>
+          <a:xfrm>
+            <a:off x="8641080" y="2423160"/>
+            <a:ext cx="2514600" cy="365760"/>
+          </a:xfrm>
+          <a:prstGeom prst="rect">
+            <a:avLst/>
+          </a:prstGeom>
+          <a:noFill/>
+          <a:ln/>
+        </p:spPr>
+        <p:txBody>
+          <a:bodyPr wrap="square" lIns="0" tIns="0" rIns="0" bIns="0" rtlCol="0" anchor="ctr"/>
+          <a:lstStyle/>
+          <a:p>
+            <a:pPr algn="ctr" indent="0" marL="0">
+              <a:buNone/>
+            </a:pPr>
+            <a:r>
+              <a:rPr lang="en-US" sz="1050" dirty="0">
+                <a:solidFill>
+                  <a:srgbClr val="6B6862"/>
+                </a:solidFill>
+                <a:latin typeface="Calibri" pitchFamily="34" charset="0"/>
+                <a:ea typeface="Calibri" pitchFamily="34" charset="-122"/>
+                <a:cs typeface="Calibri" pitchFamily="34" charset="-120"/>
+              </a:rPr>
+              <a:t>SF・NY・ロンドン</a:t>
+            </a:r>
+            <a:endParaRPr lang="en-US" sz="1050" dirty="0"/>
+          </a:p>
+        </p:txBody>
+      </p:sp>
+      <p:sp>
+        <p:nvSpPr>
+          <p:cNvPr id="17" name="Text 15"/>
+          <p:cNvSpPr txBox="1"/>
+          <p:nvPr/>
+        </p:nvSpPr>
+        <p:spPr>
+          <a:xfrm>
+            <a:off x="548640" y="3108960"/>
+            <a:ext cx="10607040" cy="320040"/>
+          </a:xfrm>
+          <a:prstGeom prst="rect">
+            <a:avLst/>
+          </a:prstGeom>
+          <a:noFill/>
+          <a:ln/>
+        </p:spPr>
+        <p:txBody>
+          <a:bodyPr wrap="square" lIns="0" tIns="0" rIns="0" bIns="0" rtlCol="0" anchor="ctr"/>
+          <a:lstStyle/>
+          <a:p>
+            <a:pPr indent="0" marL="0">
+              <a:buNone/>
+            </a:pPr>
+            <a:r>
+              <a:rPr lang="en-US" sz="1350" b="1" dirty="0">
+                <a:solidFill>
+                  <a:srgbClr val="CC785C"/>
+                </a:solidFill>
+                <a:latin typeface="Calibri" pitchFamily="34" charset="0"/>
+                <a:ea typeface="Calibri" pitchFamily="34" charset="-122"/>
+                <a:cs typeface="Calibri" pitchFamily="34" charset="-120"/>
+              </a:rPr>
+              <a:t>プログラム内容(医学研修モデル)</a:t>
+            </a:r>
+            <a:endParaRPr lang="en-US" sz="1350" dirty="0"/>
+          </a:p>
+        </p:txBody>
+      </p:sp>
+      <p:sp>
+        <p:nvSpPr>
+          <p:cNvPr id="18" name="Text 16"/>
+          <p:cNvSpPr txBox="1"/>
+          <p:nvPr/>
+        </p:nvSpPr>
+        <p:spPr>
+          <a:xfrm>
+            <a:off x="548640" y="3429000"/>
+            <a:ext cx="10607040" cy="1828800"/>
+          </a:xfrm>
+          <a:prstGeom prst="rect">
+            <a:avLst/>
+          </a:prstGeom>
+          <a:noFill/>
+          <a:ln/>
+        </p:spPr>
+        <p:txBody>
+          <a:bodyPr wrap="square" lIns="0" tIns="0" rIns="0" bIns="0" rtlCol="0" anchor="ctr"/>
+          <a:lstStyle/>
+          <a:p>
+            <a:pPr marL="342900" indent="-342900">
+              <a:spcAft>
+                <a:spcPts val="400"/>
+              </a:spcAft>
+              <a:buSzPct val="100000"/>
+              <a:buChar char="•"/>
             </a:pPr>
             <a:r>
               <a:rPr lang="en-US" sz="1100" dirty="0">
                 <a:solidFill>
+                  <a:srgbClr val="1F1E1D"/>
+                </a:solidFill>
+                <a:latin typeface="Calibri" pitchFamily="34" charset="0"/>
+                <a:ea typeface="Calibri" pitchFamily="34" charset="-122"/>
+                <a:cs typeface="Calibri" pitchFamily="34" charset="-120"/>
+              </a:rPr>
+              <a:t>① 数日間の対面研修(Anthropicのエンジニアから直接学ぶ)</a:t>
+            </a:r>
+            <a:endParaRPr lang="en-US" sz="1100" dirty="0"/>
+          </a:p>
+          <a:p>
+            <a:pPr marL="342900" indent="-342900">
+              <a:spcAft>
+                <a:spcPts val="400"/>
+              </a:spcAft>
+              <a:buSzPct val="100000"/>
+              <a:buChar char="•"/>
+            </a:pPr>
+            <a:r>
+              <a:rPr lang="en-US" sz="1100" dirty="0">
+                <a:solidFill>
+                  <a:srgbClr val="1F1E1D"/>
+                </a:solidFill>
+                <a:latin typeface="Calibri" pitchFamily="34" charset="0"/>
+                <a:ea typeface="Calibri" pitchFamily="34" charset="-122"/>
+                <a:cs typeface="Calibri" pitchFamily="34" charset="-120"/>
+              </a:rPr>
+              <a:t>② 模擬エンタープライズ導入演習(ユースケース選定〜セキュリティレビューまでを模擬体験)</a:t>
+            </a:r>
+            <a:endParaRPr lang="en-US" sz="1100" dirty="0"/>
+          </a:p>
+          <a:p>
+            <a:pPr marL="342900" indent="-342900">
+              <a:spcAft>
+                <a:spcPts val="400"/>
+              </a:spcAft>
+              <a:buSzPct val="100000"/>
+              <a:buChar char="•"/>
+            </a:pPr>
+            <a:r>
+              <a:rPr lang="en-US" sz="1100" dirty="0">
+                <a:solidFill>
+                  <a:srgbClr val="1F1E1D"/>
+                </a:solidFill>
+                <a:latin typeface="Calibri" pitchFamily="34" charset="0"/>
+                <a:ea typeface="Calibri" pitchFamily="34" charset="-122"/>
+                <a:cs typeface="Calibri" pitchFamily="34" charset="-120"/>
+              </a:rPr>
+              <a:t>③ 実技評価(グレード付きの実践アセスメント)</a:t>
+            </a:r>
+            <a:endParaRPr lang="en-US" sz="1100" dirty="0"/>
+          </a:p>
+          <a:p>
+            <a:pPr marL="342900" indent="-342900">
+              <a:spcAft>
+                <a:spcPts val="400"/>
+              </a:spcAft>
+              <a:buSzPct val="100000"/>
+              <a:buChar char="•"/>
+            </a:pPr>
+            <a:r>
+              <a:rPr lang="en-US" sz="1100" dirty="0">
+                <a:solidFill>
+                  <a:srgbClr val="1F1E1D"/>
+                </a:solidFill>
+                <a:latin typeface="Calibri" pitchFamily="34" charset="0"/>
+                <a:ea typeface="Calibri" pitchFamily="34" charset="-122"/>
+                <a:cs typeface="Calibri" pitchFamily="34" charset="-120"/>
+              </a:rPr>
+              <a:t>④ 自組織での12週間レジデンシー(持ち帰った実プロジェクトを主導)</a:t>
+            </a:r>
+            <a:endParaRPr lang="en-US" sz="1100" dirty="0"/>
+          </a:p>
+          <a:p>
+            <a:pPr marL="342900" indent="-342900">
+              <a:spcAft>
+                <a:spcPts val="400"/>
+              </a:spcAft>
+              <a:buSzPct val="100000"/>
+              <a:buChar char="•"/>
+            </a:pPr>
+            <a:r>
+              <a:rPr lang="en-US" sz="1100" dirty="0">
+                <a:solidFill>
+                  <a:srgbClr val="1F1E1D"/>
+                </a:solidFill>
+                <a:latin typeface="Calibri" pitchFamily="34" charset="0"/>
+                <a:ea typeface="Calibri" pitchFamily="34" charset="-122"/>
+                <a:cs typeface="Calibri" pitchFamily="34" charset="-120"/>
+              </a:rPr>
+              <a:t>⑤ 最終評価 → 「Claude Frontier Deployed Engineer(FDE)」バッジ取得</a:t>
+            </a:r>
+            <a:endParaRPr lang="en-US" sz="1100" dirty="0"/>
+          </a:p>
+        </p:txBody>
+      </p:sp>
+      <p:sp>
+        <p:nvSpPr>
+          <p:cNvPr id="19" name="Text 17"/>
+          <p:cNvSpPr txBox="1"/>
+          <p:nvPr/>
+        </p:nvSpPr>
+        <p:spPr>
+          <a:xfrm>
+            <a:off x="548640" y="5349240"/>
+            <a:ext cx="10607040" cy="320040"/>
+          </a:xfrm>
+          <a:prstGeom prst="rect">
+            <a:avLst/>
+          </a:prstGeom>
+          <a:noFill/>
+          <a:ln/>
+        </p:spPr>
+        <p:txBody>
+          <a:bodyPr wrap="square" lIns="0" tIns="0" rIns="0" bIns="0" rtlCol="0" anchor="ctr"/>
+          <a:lstStyle/>
+          <a:p>
+            <a:pPr indent="0" marL="0">
+              <a:buNone/>
+            </a:pPr>
+            <a:r>
+              <a:rPr lang="en-US" sz="1350" b="1" dirty="0">
+                <a:solidFill>
+                  <a:srgbClr val="CC785C"/>
+                </a:solidFill>
+                <a:latin typeface="Calibri" pitchFamily="34" charset="0"/>
+                <a:ea typeface="Calibri" pitchFamily="34" charset="-122"/>
+                <a:cs typeface="Calibri" pitchFamily="34" charset="-120"/>
+              </a:rPr>
+              <a:t>対象者・参加組織</a:t>
+            </a:r>
+            <a:endParaRPr lang="en-US" sz="1350" dirty="0"/>
+          </a:p>
+        </p:txBody>
+      </p:sp>
+      <p:sp>
+        <p:nvSpPr>
+          <p:cNvPr id="20" name="Text 18"/>
+          <p:cNvSpPr txBox="1"/>
+          <p:nvPr/>
+        </p:nvSpPr>
+        <p:spPr>
+          <a:xfrm>
+            <a:off x="548640" y="5669280"/>
+            <a:ext cx="10607040" cy="685800"/>
+          </a:xfrm>
+          <a:prstGeom prst="rect">
+            <a:avLst/>
+          </a:prstGeom>
+          <a:noFill/>
+          <a:ln/>
+        </p:spPr>
+        <p:txBody>
+          <a:bodyPr wrap="square" lIns="0" tIns="0" rIns="0" bIns="0" rtlCol="0" anchor="ctr"/>
+          <a:lstStyle/>
+          <a:p>
+            <a:pPr indent="0" marL="0">
+              <a:buNone/>
+            </a:pPr>
+            <a:r>
+              <a:rPr lang="en-US" sz="1050" dirty="0">
+                <a:solidFill>
                   <a:srgbClr val="6B6862"/>
                 </a:solidFill>
                 <a:latin typeface="Calibri" pitchFamily="34" charset="0"/>
                 <a:ea typeface="Calibri" pitchFamily="34" charset="-122"/>
                 <a:cs typeface="Calibri" pitchFamily="34" charset="-120"/>
               </a:rPr>
-              <a:t>モデルがゴール達成のためツール呼び出しを繰り返す仕組み</a:t>
-            </a:r>
-            <a:endParaRPr lang="en-US" sz="1100" dirty="0"/>
-          </a:p>
-        </p:txBody>
-      </p:sp>
-      <p:sp>
-        <p:nvSpPr>
-          <p:cNvPr id="5" name="Text 3"/>
-          <p:cNvSpPr txBox="1"/>
-          <p:nvPr/>
-        </p:nvSpPr>
-        <p:spPr>
-          <a:xfrm>
-            <a:off x="548640" y="1993392"/>
-            <a:ext cx="3108960" cy="594360"/>
-          </a:xfrm>
-          <a:prstGeom prst="rect">
-            <a:avLst/>
-          </a:prstGeom>
-          <a:noFill/>
-          <a:ln/>
-        </p:spPr>
-        <p:txBody>
-          <a:bodyPr wrap="square" lIns="0" tIns="0" rIns="0" bIns="0" rtlCol="0" anchor="t"/>
-          <a:lstStyle/>
-          <a:p>
-            <a:pPr indent="0" marL="0">
-              <a:buNone/>
-            </a:pPr>
-            <a:r>
-              <a:rPr lang="en-US" sz="1200" b="1" dirty="0">
-                <a:solidFill>
-                  <a:srgbClr val="CC785C"/>
-                </a:solidFill>
-                <a:latin typeface="Calibri" pitchFamily="34" charset="0"/>
-                <a:ea typeface="Calibri" pitchFamily="34" charset="-122"/>
-                <a:cs typeface="Calibri" pitchFamily="34" charset="-120"/>
-              </a:rPr>
-              <a:t>CLAUDE.md</a:t>
-            </a:r>
-            <a:endParaRPr lang="en-US" sz="1200" dirty="0"/>
-          </a:p>
-        </p:txBody>
-      </p:sp>
-      <p:sp>
-        <p:nvSpPr>
-          <p:cNvPr id="6" name="Text 4"/>
-          <p:cNvSpPr txBox="1"/>
-          <p:nvPr/>
-        </p:nvSpPr>
-        <p:spPr>
-          <a:xfrm>
-            <a:off x="3749040" y="1993392"/>
-            <a:ext cx="7406640" cy="594360"/>
-          </a:xfrm>
-          <a:prstGeom prst="rect">
-            <a:avLst/>
-          </a:prstGeom>
-          <a:noFill/>
-          <a:ln/>
-        </p:spPr>
-        <p:txBody>
-          <a:bodyPr wrap="square" lIns="0" tIns="0" rIns="0" bIns="0" rtlCol="0" anchor="ctr"/>
-          <a:lstStyle/>
-          <a:p>
-            <a:pPr indent="0" marL="0">
-              <a:buNone/>
-            </a:pPr>
-            <a:r>
-              <a:rPr lang="en-US" sz="1100" dirty="0">
+              <a:t>LLM活用の実績があり、社内のAI導入を推進してきたソフトウェアエンジニアを各組織が推薦。初回コホートには Accenture・Bain・Capgemini・Commonwealth Bank of Australia・Deloitte・McKinsey・Morgan Stanley・Novo Nordisk が参加。既存の「Claude Partner Network」(認定取得者17.5万人超)の発展形という位置づけ</a:t>
+            </a:r>
+            <a:endParaRPr lang="en-US" sz="1050" dirty="0"/>
+          </a:p>
+        </p:txBody>
+      </p:sp>
+      <p:sp>
+        <p:nvSpPr>
+          <p:cNvPr id="21" name="Text 19"/>
+          <p:cNvSpPr txBox="1"/>
+          <p:nvPr/>
+        </p:nvSpPr>
+        <p:spPr>
+          <a:xfrm>
+            <a:off x="548640" y="6400800"/>
+            <a:ext cx="10424160" cy="320040"/>
+          </a:xfrm>
+          <a:prstGeom prst="rect">
+            <a:avLst/>
+          </a:prstGeom>
+          <a:noFill/>
+          <a:ln/>
+        </p:spPr>
+        <p:txBody>
+          <a:bodyPr wrap="square" lIns="0" tIns="0" rIns="0" bIns="0" rtlCol="0" anchor="ctr"/>
+          <a:lstStyle/>
+          <a:p>
+            <a:pPr indent="0" marL="0">
+              <a:buNone/>
+            </a:pPr>
+            <a:r>
+              <a:rPr lang="en-US" sz="950" i="1" dirty="0">
                 <a:solidFill>
                   <a:srgbClr val="6B6862"/>
                 </a:solidFill>
@@ -26153,405 +27032,15 @@
                 <a:ea typeface="Calibri" pitchFamily="34" charset="-122"/>
                 <a:cs typeface="Calibri" pitchFamily="34" charset="-120"/>
               </a:rPr>
-              <a:t>プロジェクトの規約・文脈を記録する永続メモリファイル(/initで自動生成)</a:t>
-            </a:r>
-            <a:endParaRPr lang="en-US" sz="1100" dirty="0"/>
-          </a:p>
-        </p:txBody>
-      </p:sp>
-      <p:sp>
-        <p:nvSpPr>
-          <p:cNvPr id="7" name="Text 5"/>
-          <p:cNvSpPr txBox="1"/>
-          <p:nvPr/>
-        </p:nvSpPr>
-        <p:spPr>
-          <a:xfrm>
-            <a:off x="548640" y="2706624"/>
-            <a:ext cx="3108960" cy="594360"/>
-          </a:xfrm>
-          <a:prstGeom prst="rect">
-            <a:avLst/>
-          </a:prstGeom>
-          <a:noFill/>
-          <a:ln/>
-        </p:spPr>
-        <p:txBody>
-          <a:bodyPr wrap="square" lIns="0" tIns="0" rIns="0" bIns="0" rtlCol="0" anchor="t"/>
-          <a:lstStyle/>
-          <a:p>
-            <a:pPr indent="0" marL="0">
-              <a:buNone/>
-            </a:pPr>
-            <a:r>
-              <a:rPr lang="en-US" sz="1200" b="1" dirty="0">
-                <a:solidFill>
-                  <a:srgbClr val="CC785C"/>
-                </a:solidFill>
-                <a:latin typeface="Calibri" pitchFamily="34" charset="0"/>
-                <a:ea typeface="Calibri" pitchFamily="34" charset="-122"/>
-                <a:cs typeface="Calibri" pitchFamily="34" charset="-120"/>
-              </a:rPr>
-              <a:t>Skill / MCP / Plugin</a:t>
-            </a:r>
-            <a:endParaRPr lang="en-US" sz="1200" dirty="0"/>
-          </a:p>
-        </p:txBody>
-      </p:sp>
-      <p:sp>
-        <p:nvSpPr>
-          <p:cNvPr id="8" name="Text 6"/>
-          <p:cNvSpPr txBox="1"/>
-          <p:nvPr/>
-        </p:nvSpPr>
-        <p:spPr>
-          <a:xfrm>
-            <a:off x="3749040" y="2706624"/>
-            <a:ext cx="7406640" cy="594360"/>
-          </a:xfrm>
-          <a:prstGeom prst="rect">
-            <a:avLst/>
-          </a:prstGeom>
-          <a:noFill/>
-          <a:ln/>
-        </p:spPr>
-        <p:txBody>
-          <a:bodyPr wrap="square" lIns="0" tIns="0" rIns="0" bIns="0" rtlCol="0" anchor="ctr"/>
-          <a:lstStyle/>
-          <a:p>
-            <a:pPr indent="0" marL="0">
-              <a:buNone/>
-            </a:pPr>
-            <a:r>
-              <a:rPr lang="en-US" sz="1100" dirty="0">
-                <a:solidFill>
-                  <a:srgbClr val="6B6862"/>
-                </a:solidFill>
-                <a:latin typeface="Calibri" pitchFamily="34" charset="0"/>
-                <a:ea typeface="Calibri" pitchFamily="34" charset="-122"/>
-                <a:cs typeface="Calibri" pitchFamily="34" charset="-120"/>
-              </a:rPr>
-              <a:t>Skill=再利用可能な作業手順、MCP=外部システム接続の標準規格、Plugin=これらの配布バンドル</a:t>
-            </a:r>
-            <a:endParaRPr lang="en-US" sz="1100" dirty="0"/>
-          </a:p>
-        </p:txBody>
-      </p:sp>
-      <p:sp>
-        <p:nvSpPr>
-          <p:cNvPr id="9" name="Text 7"/>
-          <p:cNvSpPr txBox="1"/>
-          <p:nvPr/>
-        </p:nvSpPr>
-        <p:spPr>
-          <a:xfrm>
-            <a:off x="548640" y="3419856"/>
-            <a:ext cx="3108960" cy="594360"/>
-          </a:xfrm>
-          <a:prstGeom prst="rect">
-            <a:avLst/>
-          </a:prstGeom>
-          <a:noFill/>
-          <a:ln/>
-        </p:spPr>
-        <p:txBody>
-          <a:bodyPr wrap="square" lIns="0" tIns="0" rIns="0" bIns="0" rtlCol="0" anchor="t"/>
-          <a:lstStyle/>
-          <a:p>
-            <a:pPr indent="0" marL="0">
-              <a:buNone/>
-            </a:pPr>
-            <a:r>
-              <a:rPr lang="en-US" sz="1200" b="1" dirty="0">
-                <a:solidFill>
-                  <a:srgbClr val="CC785C"/>
-                </a:solidFill>
-                <a:latin typeface="Calibri" pitchFamily="34" charset="0"/>
-                <a:ea typeface="Calibri" pitchFamily="34" charset="-122"/>
-                <a:cs typeface="Calibri" pitchFamily="34" charset="-120"/>
-              </a:rPr>
-              <a:t>4Dフレームワーク</a:t>
-            </a:r>
-            <a:endParaRPr lang="en-US" sz="1200" dirty="0"/>
-          </a:p>
-        </p:txBody>
-      </p:sp>
-      <p:sp>
-        <p:nvSpPr>
-          <p:cNvPr id="10" name="Text 8"/>
-          <p:cNvSpPr txBox="1"/>
-          <p:nvPr/>
-        </p:nvSpPr>
-        <p:spPr>
-          <a:xfrm>
-            <a:off x="3749040" y="3419856"/>
-            <a:ext cx="7406640" cy="594360"/>
-          </a:xfrm>
-          <a:prstGeom prst="rect">
-            <a:avLst/>
-          </a:prstGeom>
-          <a:noFill/>
-          <a:ln/>
-        </p:spPr>
-        <p:txBody>
-          <a:bodyPr wrap="square" lIns="0" tIns="0" rIns="0" bIns="0" rtlCol="0" anchor="ctr"/>
-          <a:lstStyle/>
-          <a:p>
-            <a:pPr indent="0" marL="0">
-              <a:buNone/>
-            </a:pPr>
-            <a:r>
-              <a:rPr lang="en-US" sz="1100" dirty="0">
-                <a:solidFill>
-                  <a:srgbClr val="6B6862"/>
-                </a:solidFill>
-                <a:latin typeface="Calibri" pitchFamily="34" charset="0"/>
-                <a:ea typeface="Calibri" pitchFamily="34" charset="-122"/>
-                <a:cs typeface="Calibri" pitchFamily="34" charset="-120"/>
-              </a:rPr>
-              <a:t>Description・Discernment・Delegation・Diligenceの2重ループ</a:t>
-            </a:r>
-            <a:endParaRPr lang="en-US" sz="1100" dirty="0"/>
-          </a:p>
-        </p:txBody>
-      </p:sp>
-      <p:sp>
-        <p:nvSpPr>
-          <p:cNvPr id="11" name="Text 9"/>
-          <p:cNvSpPr txBox="1"/>
-          <p:nvPr/>
-        </p:nvSpPr>
-        <p:spPr>
-          <a:xfrm>
-            <a:off x="548640" y="4133088"/>
-            <a:ext cx="3108960" cy="594360"/>
-          </a:xfrm>
-          <a:prstGeom prst="rect">
-            <a:avLst/>
-          </a:prstGeom>
-          <a:noFill/>
-          <a:ln/>
-        </p:spPr>
-        <p:txBody>
-          <a:bodyPr wrap="square" lIns="0" tIns="0" rIns="0" bIns="0" rtlCol="0" anchor="t"/>
-          <a:lstStyle/>
-          <a:p>
-            <a:pPr indent="0" marL="0">
-              <a:buNone/>
-            </a:pPr>
-            <a:r>
-              <a:rPr lang="en-US" sz="1200" b="1" dirty="0">
-                <a:solidFill>
-                  <a:srgbClr val="CC785C"/>
-                </a:solidFill>
-                <a:latin typeface="Calibri" pitchFamily="34" charset="0"/>
-                <a:ea typeface="Calibri" pitchFamily="34" charset="-122"/>
-                <a:cs typeface="Calibri" pitchFamily="34" charset="-120"/>
-              </a:rPr>
-              <a:t>Cost avoidance / Value creation</a:t>
-            </a:r>
-            <a:endParaRPr lang="en-US" sz="1200" dirty="0"/>
-          </a:p>
-        </p:txBody>
-      </p:sp>
-      <p:sp>
-        <p:nvSpPr>
-          <p:cNvPr id="12" name="Text 10"/>
-          <p:cNvSpPr txBox="1"/>
-          <p:nvPr/>
-        </p:nvSpPr>
-        <p:spPr>
-          <a:xfrm>
-            <a:off x="3749040" y="4133088"/>
-            <a:ext cx="7406640" cy="594360"/>
-          </a:xfrm>
-          <a:prstGeom prst="rect">
-            <a:avLst/>
-          </a:prstGeom>
-          <a:noFill/>
-          <a:ln/>
-        </p:spPr>
-        <p:txBody>
-          <a:bodyPr wrap="square" lIns="0" tIns="0" rIns="0" bIns="0" rtlCol="0" anchor="ctr"/>
-          <a:lstStyle/>
-          <a:p>
-            <a:pPr indent="0" marL="0">
-              <a:buNone/>
-            </a:pPr>
-            <a:r>
-              <a:rPr lang="en-US" sz="1100" dirty="0">
-                <a:solidFill>
-                  <a:srgbClr val="6B6862"/>
-                </a:solidFill>
-                <a:latin typeface="Calibri" pitchFamily="34" charset="0"/>
-                <a:ea typeface="Calibri" pitchFamily="34" charset="-122"/>
-                <a:cs typeface="Calibri" pitchFamily="34" charset="-120"/>
-              </a:rPr>
-              <a:t>既存作業を低コスト化 / 新たな収益・成果を生み出す、という価値分類の2軸</a:t>
-            </a:r>
-            <a:endParaRPr lang="en-US" sz="1100" dirty="0"/>
-          </a:p>
-        </p:txBody>
-      </p:sp>
-      <p:sp>
-        <p:nvSpPr>
-          <p:cNvPr id="13" name="Text 11"/>
-          <p:cNvSpPr txBox="1"/>
-          <p:nvPr/>
-        </p:nvSpPr>
-        <p:spPr>
-          <a:xfrm>
-            <a:off x="548640" y="4846320"/>
-            <a:ext cx="3108960" cy="594360"/>
-          </a:xfrm>
-          <a:prstGeom prst="rect">
-            <a:avLst/>
-          </a:prstGeom>
-          <a:noFill/>
-          <a:ln/>
-        </p:spPr>
-        <p:txBody>
-          <a:bodyPr wrap="square" lIns="0" tIns="0" rIns="0" bIns="0" rtlCol="0" anchor="t"/>
-          <a:lstStyle/>
-          <a:p>
-            <a:pPr indent="0" marL="0">
-              <a:buNone/>
-            </a:pPr>
-            <a:r>
-              <a:rPr lang="en-US" sz="1200" b="1" dirty="0">
-                <a:solidFill>
-                  <a:srgbClr val="CC785C"/>
-                </a:solidFill>
-                <a:latin typeface="Calibri" pitchFamily="34" charset="0"/>
-                <a:ea typeface="Calibri" pitchFamily="34" charset="-122"/>
-                <a:cs typeface="Calibri" pitchFamily="34" charset="-120"/>
-              </a:rPr>
-              <a:t>Cowork 4段階ループ</a:t>
-            </a:r>
-            <a:endParaRPr lang="en-US" sz="1200" dirty="0"/>
-          </a:p>
-        </p:txBody>
-      </p:sp>
-      <p:sp>
-        <p:nvSpPr>
-          <p:cNvPr id="14" name="Text 12"/>
-          <p:cNvSpPr txBox="1"/>
-          <p:nvPr/>
-        </p:nvSpPr>
-        <p:spPr>
-          <a:xfrm>
-            <a:off x="3749040" y="4846320"/>
-            <a:ext cx="7406640" cy="594360"/>
-          </a:xfrm>
-          <a:prstGeom prst="rect">
-            <a:avLst/>
-          </a:prstGeom>
-          <a:noFill/>
-          <a:ln/>
-        </p:spPr>
-        <p:txBody>
-          <a:bodyPr wrap="square" lIns="0" tIns="0" rIns="0" bIns="0" rtlCol="0" anchor="ctr"/>
-          <a:lstStyle/>
-          <a:p>
-            <a:pPr indent="0" marL="0">
-              <a:buNone/>
-            </a:pPr>
-            <a:r>
-              <a:rPr lang="en-US" sz="1100" dirty="0">
-                <a:solidFill>
-                  <a:srgbClr val="6B6862"/>
-                </a:solidFill>
-                <a:latin typeface="Calibri" pitchFamily="34" charset="0"/>
-                <a:ea typeface="Calibri" pitchFamily="34" charset="-122"/>
-                <a:cs typeface="Calibri" pitchFamily="34" charset="-120"/>
-              </a:rPr>
-              <a:t>Understand→Plan→Execute→Verify &amp; Deliver</a:t>
-            </a:r>
-            <a:endParaRPr lang="en-US" sz="1100" dirty="0"/>
-          </a:p>
-        </p:txBody>
-      </p:sp>
-      <p:sp>
-        <p:nvSpPr>
-          <p:cNvPr id="15" name="Text 13"/>
-          <p:cNvSpPr txBox="1"/>
-          <p:nvPr/>
-        </p:nvSpPr>
-        <p:spPr>
-          <a:xfrm>
-            <a:off x="548640" y="5532120"/>
-            <a:ext cx="10607040" cy="320040"/>
-          </a:xfrm>
-          <a:prstGeom prst="rect">
-            <a:avLst/>
-          </a:prstGeom>
-          <a:noFill/>
-          <a:ln/>
-        </p:spPr>
-        <p:txBody>
-          <a:bodyPr wrap="square" lIns="0" tIns="0" rIns="0" bIns="0" rtlCol="0" anchor="ctr"/>
-          <a:lstStyle/>
-          <a:p>
-            <a:pPr indent="0" marL="0">
-              <a:buNone/>
-            </a:pPr>
-            <a:r>
-              <a:rPr lang="en-US" sz="1250" b="1" dirty="0">
-                <a:solidFill>
-                  <a:srgbClr val="1F1E1D"/>
-                </a:solidFill>
-                <a:latin typeface="Calibri" pitchFamily="34" charset="0"/>
-                <a:ea typeface="Calibri" pitchFamily="34" charset="-122"/>
-                <a:cs typeface="Calibri" pitchFamily="34" charset="-120"/>
-              </a:rPr>
-              <a:t>このノートの位置づけ</a:t>
-            </a:r>
-            <a:endParaRPr lang="en-US" sz="1250" dirty="0"/>
-          </a:p>
-        </p:txBody>
-      </p:sp>
-      <p:sp>
-        <p:nvSpPr>
-          <p:cNvPr id="16" name="Text 14"/>
-          <p:cNvSpPr txBox="1"/>
-          <p:nvPr/>
-        </p:nvSpPr>
-        <p:spPr>
-          <a:xfrm>
-            <a:off x="548640" y="5852160"/>
-            <a:ext cx="10607040" cy="640080"/>
-          </a:xfrm>
-          <a:prstGeom prst="rect">
-            <a:avLst/>
-          </a:prstGeom>
-          <a:noFill/>
-          <a:ln/>
-        </p:spPr>
-        <p:txBody>
-          <a:bodyPr wrap="square" lIns="0" tIns="0" rIns="0" bIns="0" rtlCol="0" anchor="ctr"/>
-          <a:lstStyle/>
-          <a:p>
-            <a:pPr indent="0" marL="0">
-              <a:buNone/>
-            </a:pPr>
-            <a:r>
-              <a:rPr lang="en-US" sz="1100" i="1" dirty="0">
-                <a:solidFill>
-                  <a:srgbClr val="6B6862"/>
-                </a:solidFill>
-                <a:latin typeface="Calibri" pitchFamily="34" charset="0"/>
-                <a:ea typeface="Calibri" pitchFamily="34" charset="-122"/>
-                <a:cs typeface="Calibri" pitchFamily="34" charset="-120"/>
-              </a:rPr>
-              <a:t>Claude CCA-F試験対策やGitHub攻略法とは別の「Anthropic公式トレーニング資料(Academy・Camp)」の学習ノートとして、今後もセッションや資料が増えるたびに改版していく想定</a:t>
-            </a:r>
-            <a:endParaRPr lang="en-US" sz="1100" dirty="0"/>
-          </a:p>
-        </p:txBody>
-      </p:sp>
-      <p:sp>
-        <p:nvSpPr>
-          <p:cNvPr id="17" name="Text 15"/>
+              <a:t>出典: Anthropic公式ニュース「Claude Frontier Academy」(anthropic.com/news/claude-frontier-academy)</a:t>
+            </a:r>
+            <a:endParaRPr lang="en-US" sz="950" dirty="0"/>
+          </a:p>
+        </p:txBody>
+      </p:sp>
+      <p:sp>
+        <p:nvSpPr>
+          <p:cNvPr id="22" name="Text 20"/>
           <p:cNvSpPr txBox="1"/>
           <p:nvPr/>
         </p:nvSpPr>
@@ -27288,6 +27777,662 @@
                 <a:cs typeface="Calibri" pitchFamily="34" charset="-120"/>
               </a:rPr>
               <a:t>4</a:t>
+            </a:r>
+            <a:endParaRPr lang="en-US" sz="1000" dirty="0"/>
+          </a:p>
+        </p:txBody>
+      </p:sp>
+    </p:spTree>
+  </p:cSld>
+  <p:clrMapOvr>
+    <a:masterClrMapping/>
+  </p:clrMapOvr>
+</p:sld>
+</file>
+
+<file path=ppt/slides/slide40.xml><?xml version="1.0" encoding="utf-8"?>
+<p:sld xmlns:a="http://schemas.openxmlformats.org/drawingml/2006/main" xmlns:r="http://schemas.openxmlformats.org/officeDocument/2006/relationships" xmlns:p="http://schemas.openxmlformats.org/presentationml/2006/main">
+  <p:cSld name="Slide 40">
+    <p:bg>
+      <p:bgPr>
+        <a:solidFill>
+          <a:srgbClr val="FFFFFF"/>
+        </a:solidFill>
+      </p:bgPr>
+    </p:bg>
+    <p:spTree>
+      <p:nvGrpSpPr>
+        <p:cNvPr id="1" name=""/>
+        <p:cNvGrpSpPr/>
+        <p:nvPr/>
+      </p:nvGrpSpPr>
+      <p:grpSpPr>
+        <a:xfrm>
+          <a:off x="0" y="0"/>
+          <a:ext cx="0" cy="0"/>
+          <a:chOff x="0" y="0"/>
+          <a:chExt cx="0" cy="0"/>
+        </a:xfrm>
+      </p:grpSpPr>
+      <p:sp>
+        <p:nvSpPr>
+          <p:cNvPr id="2" name="Text 0"/>
+          <p:cNvSpPr txBox="1"/>
+          <p:nvPr/>
+        </p:nvSpPr>
+        <p:spPr>
+          <a:xfrm>
+            <a:off x="548640" y="457200"/>
+            <a:ext cx="10607040" cy="640080"/>
+          </a:xfrm>
+          <a:prstGeom prst="rect">
+            <a:avLst/>
+          </a:prstGeom>
+          <a:noFill/>
+          <a:ln/>
+        </p:spPr>
+        <p:txBody>
+          <a:bodyPr wrap="square" lIns="0" tIns="0" rIns="0" bIns="0" rtlCol="0" anchor="ctr"/>
+          <a:lstStyle/>
+          <a:p>
+            <a:pPr indent="0" marL="0">
+              <a:buNone/>
+            </a:pPr>
+            <a:r>
+              <a:rPr lang="en-US" sz="3000" b="1" dirty="0">
+                <a:solidFill>
+                  <a:srgbClr val="1F1E1D"/>
+                </a:solidFill>
+                <a:latin typeface="Cambria" pitchFamily="34" charset="0"/>
+                <a:ea typeface="Cambria" pitchFamily="34" charset="-122"/>
+                <a:cs typeface="Cambria" pitchFamily="34" charset="-120"/>
+              </a:rPr>
+              <a:t>用語集・まとめ</a:t>
+            </a:r>
+            <a:endParaRPr lang="en-US" sz="3000" dirty="0"/>
+          </a:p>
+        </p:txBody>
+      </p:sp>
+      <p:sp>
+        <p:nvSpPr>
+          <p:cNvPr id="3" name="Text 1"/>
+          <p:cNvSpPr txBox="1"/>
+          <p:nvPr/>
+        </p:nvSpPr>
+        <p:spPr>
+          <a:xfrm>
+            <a:off x="548640" y="1280160"/>
+            <a:ext cx="3108960" cy="594360"/>
+          </a:xfrm>
+          <a:prstGeom prst="rect">
+            <a:avLst/>
+          </a:prstGeom>
+          <a:noFill/>
+          <a:ln/>
+        </p:spPr>
+        <p:txBody>
+          <a:bodyPr wrap="square" lIns="0" tIns="0" rIns="0" bIns="0" rtlCol="0" anchor="t"/>
+          <a:lstStyle/>
+          <a:p>
+            <a:pPr indent="0" marL="0">
+              <a:buNone/>
+            </a:pPr>
+            <a:r>
+              <a:rPr lang="en-US" sz="1200" b="1" dirty="0">
+                <a:solidFill>
+                  <a:srgbClr val="CC785C"/>
+                </a:solidFill>
+                <a:latin typeface="Calibri" pitchFamily="34" charset="0"/>
+                <a:ea typeface="Calibri" pitchFamily="34" charset="-122"/>
+                <a:cs typeface="Calibri" pitchFamily="34" charset="-120"/>
+              </a:rPr>
+              <a:t>エージェントループ</a:t>
+            </a:r>
+            <a:endParaRPr lang="en-US" sz="1200" dirty="0"/>
+          </a:p>
+        </p:txBody>
+      </p:sp>
+      <p:sp>
+        <p:nvSpPr>
+          <p:cNvPr id="4" name="Text 2"/>
+          <p:cNvSpPr txBox="1"/>
+          <p:nvPr/>
+        </p:nvSpPr>
+        <p:spPr>
+          <a:xfrm>
+            <a:off x="3749040" y="1280160"/>
+            <a:ext cx="7406640" cy="594360"/>
+          </a:xfrm>
+          <a:prstGeom prst="rect">
+            <a:avLst/>
+          </a:prstGeom>
+          <a:noFill/>
+          <a:ln/>
+        </p:spPr>
+        <p:txBody>
+          <a:bodyPr wrap="square" lIns="0" tIns="0" rIns="0" bIns="0" rtlCol="0" anchor="ctr"/>
+          <a:lstStyle/>
+          <a:p>
+            <a:pPr indent="0" marL="0">
+              <a:buNone/>
+            </a:pPr>
+            <a:r>
+              <a:rPr lang="en-US" sz="1100" dirty="0">
+                <a:solidFill>
+                  <a:srgbClr val="6B6862"/>
+                </a:solidFill>
+                <a:latin typeface="Calibri" pitchFamily="34" charset="0"/>
+                <a:ea typeface="Calibri" pitchFamily="34" charset="-122"/>
+                <a:cs typeface="Calibri" pitchFamily="34" charset="-120"/>
+              </a:rPr>
+              <a:t>モデルがゴール達成のためツール呼び出しを繰り返す仕組み</a:t>
+            </a:r>
+            <a:endParaRPr lang="en-US" sz="1100" dirty="0"/>
+          </a:p>
+        </p:txBody>
+      </p:sp>
+      <p:sp>
+        <p:nvSpPr>
+          <p:cNvPr id="5" name="Text 3"/>
+          <p:cNvSpPr txBox="1"/>
+          <p:nvPr/>
+        </p:nvSpPr>
+        <p:spPr>
+          <a:xfrm>
+            <a:off x="548640" y="1993392"/>
+            <a:ext cx="3108960" cy="594360"/>
+          </a:xfrm>
+          <a:prstGeom prst="rect">
+            <a:avLst/>
+          </a:prstGeom>
+          <a:noFill/>
+          <a:ln/>
+        </p:spPr>
+        <p:txBody>
+          <a:bodyPr wrap="square" lIns="0" tIns="0" rIns="0" bIns="0" rtlCol="0" anchor="t"/>
+          <a:lstStyle/>
+          <a:p>
+            <a:pPr indent="0" marL="0">
+              <a:buNone/>
+            </a:pPr>
+            <a:r>
+              <a:rPr lang="en-US" sz="1200" b="1" dirty="0">
+                <a:solidFill>
+                  <a:srgbClr val="CC785C"/>
+                </a:solidFill>
+                <a:latin typeface="Calibri" pitchFamily="34" charset="0"/>
+                <a:ea typeface="Calibri" pitchFamily="34" charset="-122"/>
+                <a:cs typeface="Calibri" pitchFamily="34" charset="-120"/>
+              </a:rPr>
+              <a:t>CLAUDE.md</a:t>
+            </a:r>
+            <a:endParaRPr lang="en-US" sz="1200" dirty="0"/>
+          </a:p>
+        </p:txBody>
+      </p:sp>
+      <p:sp>
+        <p:nvSpPr>
+          <p:cNvPr id="6" name="Text 4"/>
+          <p:cNvSpPr txBox="1"/>
+          <p:nvPr/>
+        </p:nvSpPr>
+        <p:spPr>
+          <a:xfrm>
+            <a:off x="3749040" y="1993392"/>
+            <a:ext cx="7406640" cy="594360"/>
+          </a:xfrm>
+          <a:prstGeom prst="rect">
+            <a:avLst/>
+          </a:prstGeom>
+          <a:noFill/>
+          <a:ln/>
+        </p:spPr>
+        <p:txBody>
+          <a:bodyPr wrap="square" lIns="0" tIns="0" rIns="0" bIns="0" rtlCol="0" anchor="ctr"/>
+          <a:lstStyle/>
+          <a:p>
+            <a:pPr indent="0" marL="0">
+              <a:buNone/>
+            </a:pPr>
+            <a:r>
+              <a:rPr lang="en-US" sz="1100" dirty="0">
+                <a:solidFill>
+                  <a:srgbClr val="6B6862"/>
+                </a:solidFill>
+                <a:latin typeface="Calibri" pitchFamily="34" charset="0"/>
+                <a:ea typeface="Calibri" pitchFamily="34" charset="-122"/>
+                <a:cs typeface="Calibri" pitchFamily="34" charset="-120"/>
+              </a:rPr>
+              <a:t>プロジェクトの規約・文脈を記録する永続メモリファイル(/initで自動生成)</a:t>
+            </a:r>
+            <a:endParaRPr lang="en-US" sz="1100" dirty="0"/>
+          </a:p>
+        </p:txBody>
+      </p:sp>
+      <p:sp>
+        <p:nvSpPr>
+          <p:cNvPr id="7" name="Text 5"/>
+          <p:cNvSpPr txBox="1"/>
+          <p:nvPr/>
+        </p:nvSpPr>
+        <p:spPr>
+          <a:xfrm>
+            <a:off x="548640" y="2706624"/>
+            <a:ext cx="3108960" cy="594360"/>
+          </a:xfrm>
+          <a:prstGeom prst="rect">
+            <a:avLst/>
+          </a:prstGeom>
+          <a:noFill/>
+          <a:ln/>
+        </p:spPr>
+        <p:txBody>
+          <a:bodyPr wrap="square" lIns="0" tIns="0" rIns="0" bIns="0" rtlCol="0" anchor="t"/>
+          <a:lstStyle/>
+          <a:p>
+            <a:pPr indent="0" marL="0">
+              <a:buNone/>
+            </a:pPr>
+            <a:r>
+              <a:rPr lang="en-US" sz="1200" b="1" dirty="0">
+                <a:solidFill>
+                  <a:srgbClr val="CC785C"/>
+                </a:solidFill>
+                <a:latin typeface="Calibri" pitchFamily="34" charset="0"/>
+                <a:ea typeface="Calibri" pitchFamily="34" charset="-122"/>
+                <a:cs typeface="Calibri" pitchFamily="34" charset="-120"/>
+              </a:rPr>
+              <a:t>Skill / MCP / Plugin</a:t>
+            </a:r>
+            <a:endParaRPr lang="en-US" sz="1200" dirty="0"/>
+          </a:p>
+        </p:txBody>
+      </p:sp>
+      <p:sp>
+        <p:nvSpPr>
+          <p:cNvPr id="8" name="Text 6"/>
+          <p:cNvSpPr txBox="1"/>
+          <p:nvPr/>
+        </p:nvSpPr>
+        <p:spPr>
+          <a:xfrm>
+            <a:off x="3749040" y="2706624"/>
+            <a:ext cx="7406640" cy="594360"/>
+          </a:xfrm>
+          <a:prstGeom prst="rect">
+            <a:avLst/>
+          </a:prstGeom>
+          <a:noFill/>
+          <a:ln/>
+        </p:spPr>
+        <p:txBody>
+          <a:bodyPr wrap="square" lIns="0" tIns="0" rIns="0" bIns="0" rtlCol="0" anchor="ctr"/>
+          <a:lstStyle/>
+          <a:p>
+            <a:pPr indent="0" marL="0">
+              <a:buNone/>
+            </a:pPr>
+            <a:r>
+              <a:rPr lang="en-US" sz="1100" dirty="0">
+                <a:solidFill>
+                  <a:srgbClr val="6B6862"/>
+                </a:solidFill>
+                <a:latin typeface="Calibri" pitchFamily="34" charset="0"/>
+                <a:ea typeface="Calibri" pitchFamily="34" charset="-122"/>
+                <a:cs typeface="Calibri" pitchFamily="34" charset="-120"/>
+              </a:rPr>
+              <a:t>Skill=再利用可能な作業手順、MCP=外部システム接続の標準規格、Plugin=これらの配布バンドル</a:t>
+            </a:r>
+            <a:endParaRPr lang="en-US" sz="1100" dirty="0"/>
+          </a:p>
+        </p:txBody>
+      </p:sp>
+      <p:sp>
+        <p:nvSpPr>
+          <p:cNvPr id="9" name="Text 7"/>
+          <p:cNvSpPr txBox="1"/>
+          <p:nvPr/>
+        </p:nvSpPr>
+        <p:spPr>
+          <a:xfrm>
+            <a:off x="548640" y="3419856"/>
+            <a:ext cx="3108960" cy="594360"/>
+          </a:xfrm>
+          <a:prstGeom prst="rect">
+            <a:avLst/>
+          </a:prstGeom>
+          <a:noFill/>
+          <a:ln/>
+        </p:spPr>
+        <p:txBody>
+          <a:bodyPr wrap="square" lIns="0" tIns="0" rIns="0" bIns="0" rtlCol="0" anchor="t"/>
+          <a:lstStyle/>
+          <a:p>
+            <a:pPr indent="0" marL="0">
+              <a:buNone/>
+            </a:pPr>
+            <a:r>
+              <a:rPr lang="en-US" sz="1200" b="1" dirty="0">
+                <a:solidFill>
+                  <a:srgbClr val="CC785C"/>
+                </a:solidFill>
+                <a:latin typeface="Calibri" pitchFamily="34" charset="0"/>
+                <a:ea typeface="Calibri" pitchFamily="34" charset="-122"/>
+                <a:cs typeface="Calibri" pitchFamily="34" charset="-120"/>
+              </a:rPr>
+              <a:t>4Dフレームワーク</a:t>
+            </a:r>
+            <a:endParaRPr lang="en-US" sz="1200" dirty="0"/>
+          </a:p>
+        </p:txBody>
+      </p:sp>
+      <p:sp>
+        <p:nvSpPr>
+          <p:cNvPr id="10" name="Text 8"/>
+          <p:cNvSpPr txBox="1"/>
+          <p:nvPr/>
+        </p:nvSpPr>
+        <p:spPr>
+          <a:xfrm>
+            <a:off x="3749040" y="3419856"/>
+            <a:ext cx="7406640" cy="594360"/>
+          </a:xfrm>
+          <a:prstGeom prst="rect">
+            <a:avLst/>
+          </a:prstGeom>
+          <a:noFill/>
+          <a:ln/>
+        </p:spPr>
+        <p:txBody>
+          <a:bodyPr wrap="square" lIns="0" tIns="0" rIns="0" bIns="0" rtlCol="0" anchor="ctr"/>
+          <a:lstStyle/>
+          <a:p>
+            <a:pPr indent="0" marL="0">
+              <a:buNone/>
+            </a:pPr>
+            <a:r>
+              <a:rPr lang="en-US" sz="1100" dirty="0">
+                <a:solidFill>
+                  <a:srgbClr val="6B6862"/>
+                </a:solidFill>
+                <a:latin typeface="Calibri" pitchFamily="34" charset="0"/>
+                <a:ea typeface="Calibri" pitchFamily="34" charset="-122"/>
+                <a:cs typeface="Calibri" pitchFamily="34" charset="-120"/>
+              </a:rPr>
+              <a:t>Description・Discernment・Delegation・Diligenceの2重ループ</a:t>
+            </a:r>
+            <a:endParaRPr lang="en-US" sz="1100" dirty="0"/>
+          </a:p>
+        </p:txBody>
+      </p:sp>
+      <p:sp>
+        <p:nvSpPr>
+          <p:cNvPr id="11" name="Text 9"/>
+          <p:cNvSpPr txBox="1"/>
+          <p:nvPr/>
+        </p:nvSpPr>
+        <p:spPr>
+          <a:xfrm>
+            <a:off x="548640" y="4133088"/>
+            <a:ext cx="3108960" cy="594360"/>
+          </a:xfrm>
+          <a:prstGeom prst="rect">
+            <a:avLst/>
+          </a:prstGeom>
+          <a:noFill/>
+          <a:ln/>
+        </p:spPr>
+        <p:txBody>
+          <a:bodyPr wrap="square" lIns="0" tIns="0" rIns="0" bIns="0" rtlCol="0" anchor="t"/>
+          <a:lstStyle/>
+          <a:p>
+            <a:pPr indent="0" marL="0">
+              <a:buNone/>
+            </a:pPr>
+            <a:r>
+              <a:rPr lang="en-US" sz="1200" b="1" dirty="0">
+                <a:solidFill>
+                  <a:srgbClr val="CC785C"/>
+                </a:solidFill>
+                <a:latin typeface="Calibri" pitchFamily="34" charset="0"/>
+                <a:ea typeface="Calibri" pitchFamily="34" charset="-122"/>
+                <a:cs typeface="Calibri" pitchFamily="34" charset="-120"/>
+              </a:rPr>
+              <a:t>Cost avoidance / Value creation</a:t>
+            </a:r>
+            <a:endParaRPr lang="en-US" sz="1200" dirty="0"/>
+          </a:p>
+        </p:txBody>
+      </p:sp>
+      <p:sp>
+        <p:nvSpPr>
+          <p:cNvPr id="12" name="Text 10"/>
+          <p:cNvSpPr txBox="1"/>
+          <p:nvPr/>
+        </p:nvSpPr>
+        <p:spPr>
+          <a:xfrm>
+            <a:off x="3749040" y="4133088"/>
+            <a:ext cx="7406640" cy="594360"/>
+          </a:xfrm>
+          <a:prstGeom prst="rect">
+            <a:avLst/>
+          </a:prstGeom>
+          <a:noFill/>
+          <a:ln/>
+        </p:spPr>
+        <p:txBody>
+          <a:bodyPr wrap="square" lIns="0" tIns="0" rIns="0" bIns="0" rtlCol="0" anchor="ctr"/>
+          <a:lstStyle/>
+          <a:p>
+            <a:pPr indent="0" marL="0">
+              <a:buNone/>
+            </a:pPr>
+            <a:r>
+              <a:rPr lang="en-US" sz="1100" dirty="0">
+                <a:solidFill>
+                  <a:srgbClr val="6B6862"/>
+                </a:solidFill>
+                <a:latin typeface="Calibri" pitchFamily="34" charset="0"/>
+                <a:ea typeface="Calibri" pitchFamily="34" charset="-122"/>
+                <a:cs typeface="Calibri" pitchFamily="34" charset="-120"/>
+              </a:rPr>
+              <a:t>既存作業を低コスト化 / 新たな収益・成果を生み出す、という価値分類の2軸</a:t>
+            </a:r>
+            <a:endParaRPr lang="en-US" sz="1100" dirty="0"/>
+          </a:p>
+        </p:txBody>
+      </p:sp>
+      <p:sp>
+        <p:nvSpPr>
+          <p:cNvPr id="13" name="Text 11"/>
+          <p:cNvSpPr txBox="1"/>
+          <p:nvPr/>
+        </p:nvSpPr>
+        <p:spPr>
+          <a:xfrm>
+            <a:off x="548640" y="4846320"/>
+            <a:ext cx="3108960" cy="594360"/>
+          </a:xfrm>
+          <a:prstGeom prst="rect">
+            <a:avLst/>
+          </a:prstGeom>
+          <a:noFill/>
+          <a:ln/>
+        </p:spPr>
+        <p:txBody>
+          <a:bodyPr wrap="square" lIns="0" tIns="0" rIns="0" bIns="0" rtlCol="0" anchor="t"/>
+          <a:lstStyle/>
+          <a:p>
+            <a:pPr indent="0" marL="0">
+              <a:buNone/>
+            </a:pPr>
+            <a:r>
+              <a:rPr lang="en-US" sz="1200" b="1" dirty="0">
+                <a:solidFill>
+                  <a:srgbClr val="CC785C"/>
+                </a:solidFill>
+                <a:latin typeface="Calibri" pitchFamily="34" charset="0"/>
+                <a:ea typeface="Calibri" pitchFamily="34" charset="-122"/>
+                <a:cs typeface="Calibri" pitchFamily="34" charset="-120"/>
+              </a:rPr>
+              <a:t>Cowork 4段階ループ</a:t>
+            </a:r>
+            <a:endParaRPr lang="en-US" sz="1200" dirty="0"/>
+          </a:p>
+        </p:txBody>
+      </p:sp>
+      <p:sp>
+        <p:nvSpPr>
+          <p:cNvPr id="14" name="Text 12"/>
+          <p:cNvSpPr txBox="1"/>
+          <p:nvPr/>
+        </p:nvSpPr>
+        <p:spPr>
+          <a:xfrm>
+            <a:off x="3749040" y="4846320"/>
+            <a:ext cx="7406640" cy="594360"/>
+          </a:xfrm>
+          <a:prstGeom prst="rect">
+            <a:avLst/>
+          </a:prstGeom>
+          <a:noFill/>
+          <a:ln/>
+        </p:spPr>
+        <p:txBody>
+          <a:bodyPr wrap="square" lIns="0" tIns="0" rIns="0" bIns="0" rtlCol="0" anchor="ctr"/>
+          <a:lstStyle/>
+          <a:p>
+            <a:pPr indent="0" marL="0">
+              <a:buNone/>
+            </a:pPr>
+            <a:r>
+              <a:rPr lang="en-US" sz="1100" dirty="0">
+                <a:solidFill>
+                  <a:srgbClr val="6B6862"/>
+                </a:solidFill>
+                <a:latin typeface="Calibri" pitchFamily="34" charset="0"/>
+                <a:ea typeface="Calibri" pitchFamily="34" charset="-122"/>
+                <a:cs typeface="Calibri" pitchFamily="34" charset="-120"/>
+              </a:rPr>
+              <a:t>Understand→Plan→Execute→Verify &amp; Deliver</a:t>
+            </a:r>
+            <a:endParaRPr lang="en-US" sz="1100" dirty="0"/>
+          </a:p>
+        </p:txBody>
+      </p:sp>
+      <p:sp>
+        <p:nvSpPr>
+          <p:cNvPr id="15" name="Text 13"/>
+          <p:cNvSpPr txBox="1"/>
+          <p:nvPr/>
+        </p:nvSpPr>
+        <p:spPr>
+          <a:xfrm>
+            <a:off x="548640" y="5532120"/>
+            <a:ext cx="10607040" cy="320040"/>
+          </a:xfrm>
+          <a:prstGeom prst="rect">
+            <a:avLst/>
+          </a:prstGeom>
+          <a:noFill/>
+          <a:ln/>
+        </p:spPr>
+        <p:txBody>
+          <a:bodyPr wrap="square" lIns="0" tIns="0" rIns="0" bIns="0" rtlCol="0" anchor="ctr"/>
+          <a:lstStyle/>
+          <a:p>
+            <a:pPr indent="0" marL="0">
+              <a:buNone/>
+            </a:pPr>
+            <a:r>
+              <a:rPr lang="en-US" sz="1250" b="1" dirty="0">
+                <a:solidFill>
+                  <a:srgbClr val="1F1E1D"/>
+                </a:solidFill>
+                <a:latin typeface="Calibri" pitchFamily="34" charset="0"/>
+                <a:ea typeface="Calibri" pitchFamily="34" charset="-122"/>
+                <a:cs typeface="Calibri" pitchFamily="34" charset="-120"/>
+              </a:rPr>
+              <a:t>このノートの位置づけ</a:t>
+            </a:r>
+            <a:endParaRPr lang="en-US" sz="1250" dirty="0"/>
+          </a:p>
+        </p:txBody>
+      </p:sp>
+      <p:sp>
+        <p:nvSpPr>
+          <p:cNvPr id="16" name="Text 14"/>
+          <p:cNvSpPr txBox="1"/>
+          <p:nvPr/>
+        </p:nvSpPr>
+        <p:spPr>
+          <a:xfrm>
+            <a:off x="548640" y="5852160"/>
+            <a:ext cx="10607040" cy="640080"/>
+          </a:xfrm>
+          <a:prstGeom prst="rect">
+            <a:avLst/>
+          </a:prstGeom>
+          <a:noFill/>
+          <a:ln/>
+        </p:spPr>
+        <p:txBody>
+          <a:bodyPr wrap="square" lIns="0" tIns="0" rIns="0" bIns="0" rtlCol="0" anchor="ctr"/>
+          <a:lstStyle/>
+          <a:p>
+            <a:pPr indent="0" marL="0">
+              <a:buNone/>
+            </a:pPr>
+            <a:r>
+              <a:rPr lang="en-US" sz="1100" i="1" dirty="0">
+                <a:solidFill>
+                  <a:srgbClr val="6B6862"/>
+                </a:solidFill>
+                <a:latin typeface="Calibri" pitchFamily="34" charset="0"/>
+                <a:ea typeface="Calibri" pitchFamily="34" charset="-122"/>
+                <a:cs typeface="Calibri" pitchFamily="34" charset="-120"/>
+              </a:rPr>
+              <a:t>Claude CCA-F試験対策やGitHub攻略法とは別の「Anthropic公式トレーニング資料(Academy・Camp)」の学習ノートとして、今後もセッションや資料が増えるたびに改版していく想定</a:t>
+            </a:r>
+            <a:endParaRPr lang="en-US" sz="1100" dirty="0"/>
+          </a:p>
+        </p:txBody>
+      </p:sp>
+      <p:sp>
+        <p:nvSpPr>
+          <p:cNvPr id="17" name="Text 15"/>
+          <p:cNvSpPr txBox="1"/>
+          <p:nvPr/>
+        </p:nvSpPr>
+        <p:spPr>
+          <a:xfrm>
+            <a:off x="11521440" y="6492240"/>
+            <a:ext cx="457200" cy="274320"/>
+          </a:xfrm>
+          <a:prstGeom prst="rect">
+            <a:avLst/>
+          </a:prstGeom>
+          <a:noFill/>
+          <a:ln/>
+        </p:spPr>
+        <p:txBody>
+          <a:bodyPr wrap="square" lIns="0" tIns="0" rIns="0" bIns="0" rtlCol="0" anchor="ctr"/>
+          <a:lstStyle/>
+          <a:p>
+            <a:pPr algn="r" indent="0" marL="0">
+              <a:buNone/>
+            </a:pPr>
+            <a:r>
+              <a:rPr lang="en-US" sz="1000" dirty="0">
+                <a:solidFill>
+                  <a:srgbClr val="6B6862"/>
+                </a:solidFill>
+                <a:latin typeface="Calibri" pitchFamily="34" charset="0"/>
+                <a:ea typeface="Calibri" pitchFamily="34" charset="-122"/>
+                <a:cs typeface="Calibri" pitchFamily="34" charset="-120"/>
+              </a:rPr>
+              <a:t>40</a:t>
             </a:r>
             <a:endParaRPr lang="en-US" sz="1000" dirty="0"/>
           </a:p>

</xml_diff>